<commit_message>
Regenerate PowerPoint for song #3 in fubc-en
</commit_message>
<xml_diff>
--- a/fubc-en/3-God Is for Us.pptx
+++ b/fubc-en/3-God Is for Us.pptx
@@ -12,9 +12,10 @@
     <p:sldId id="260" r:id="rId6"/>
     <p:sldId id="261" r:id="rId7"/>
     <p:sldId id="262" r:id="rId8"/>
+    <p:sldId id="263" r:id="rId9"/>
   </p:sldIdLst>
   <p:notesMasterIdLst>
-    <p:notesMasterId r:id="rId9"/>
+    <p:notesMasterId r:id="rId10"/>
   </p:notesMasterIdLst>
   <p:sldSz cx="12192000" cy="6858000"/>
   <p:notesSz cx="6858000" cy="12192000"/>
@@ -1060,6 +1061,94 @@
             <a:fld id="{F7021451-1387-4CA6-816F-3879F97B5CBC}" type="slidenum">
               <a:rPr lang="en-US"/>
               <a:t>7</a:t>
+            </a:fld>
+            <a:endParaRPr lang="en-US"/>
+          </a:p>
+        </p:txBody>
+      </p:sp>
+    </p:spTree>
+    <p:extLst>
+      <p:ext uri="{BB962C8B-B14F-4D97-AF65-F5344CB8AC3E}">
+        <p14:creationId xmlns:p14="http://schemas.microsoft.com/office/powerpoint/2010/main" val="1024086991"/>
+      </p:ext>
+    </p:extLst>
+  </p:cSld>
+  <p:clrMapOvr>
+    <a:masterClrMapping/>
+  </p:clrMapOvr>
+</p:notes>
+</file>
+
+<file path=ppt/notesSlides/notesSlide8.xml><?xml version="1.0" encoding="utf-8"?>
+<p:notes xmlns:a="http://schemas.openxmlformats.org/drawingml/2006/main" xmlns:r="http://schemas.openxmlformats.org/officeDocument/2006/relationships" xmlns:p="http://schemas.openxmlformats.org/presentationml/2006/main">
+  <p:cSld>
+    <p:spTree>
+      <p:nvGrpSpPr>
+        <p:cNvPr id="1" name=""/>
+        <p:cNvGrpSpPr/>
+        <p:nvPr/>
+      </p:nvGrpSpPr>
+      <p:grpSpPr>
+        <a:xfrm>
+          <a:off x="0" y="0"/>
+          <a:ext cx="0" cy="0"/>
+          <a:chOff x="0" y="0"/>
+          <a:chExt cx="0" cy="0"/>
+        </a:xfrm>
+      </p:grpSpPr>
+      <p:sp>
+        <p:nvSpPr>
+          <p:cNvPr id="2" name="Slide Image Placeholder 1"/>
+          <p:cNvSpPr>
+            <a:spLocks noGrp="1" noRot="1" noChangeAspect="1"/>
+          </p:cNvSpPr>
+          <p:nvPr>
+            <p:ph type="sldImg"/>
+          </p:nvPr>
+        </p:nvSpPr>
+        <p:spPr/>
+      </p:sp>
+      <p:sp>
+        <p:nvSpPr>
+          <p:cNvPr id="3" name="Notes Placeholder 2"/>
+          <p:cNvSpPr>
+            <a:spLocks noGrp="1"/>
+          </p:cNvSpPr>
+          <p:nvPr>
+            <p:ph type="body" idx="1"/>
+          </p:nvPr>
+        </p:nvSpPr>
+        <p:spPr/>
+        <p:txBody>
+          <a:bodyPr/>
+          <a:lstStyle/>
+          <a:p>
+            <a:r>
+              <a:rPr lang="en-US" dirty="0"/>
+              <a:t/>
+            </a:r>
+            <a:endParaRPr lang="en-US" dirty="0"/>
+          </a:p>
+        </p:txBody>
+      </p:sp>
+      <p:sp>
+        <p:nvSpPr>
+          <p:cNvPr id="4" name="Slide Number Placeholder 3"/>
+          <p:cNvSpPr>
+            <a:spLocks noGrp="1"/>
+          </p:cNvSpPr>
+          <p:nvPr>
+            <p:ph type="sldNum" sz="quarter" idx="10"/>
+          </p:nvPr>
+        </p:nvSpPr>
+        <p:spPr/>
+        <p:txBody>
+          <a:bodyPr/>
+          <a:lstStyle/>
+          <a:p>
+            <a:fld id="{F7021451-1387-4CA6-816F-3879F97B5CBC}" type="slidenum">
+              <a:rPr lang="en-US"/>
+              <a:t>8</a:t>
             </a:fld>
             <a:endParaRPr lang="en-US"/>
           </a:p>
@@ -1434,68 +1523,17 @@
               <a:buNone/>
             </a:pPr>
             <a:r>
-              <a:rPr lang="en-US" sz="4000" b="1" dirty="0">
-                <a:solidFill>
-                  <a:srgbClr val="FFFFFF"/>
-                </a:solidFill>
-                <a:latin typeface="Arial" pitchFamily="34" charset="0"/>
-                <a:ea typeface="Arial" pitchFamily="34" charset="-122"/>
-                <a:cs typeface="Arial" pitchFamily="34" charset="-120"/>
-              </a:rPr>
-              <a:t>We won't fear the battle, we won’t fear the night</a:t>
-            </a:r>
-            <a:endParaRPr lang="en-US" sz="4000" dirty="0"/>
-          </a:p>
-          <a:p>
-            <a:pPr algn="ctr" indent="0" marL="0">
-              <a:buNone/>
-            </a:pPr>
-            <a:r>
-              <a:rPr lang="en-US" sz="4000" b="1" dirty="0">
-                <a:solidFill>
-                  <a:srgbClr val="FFFFFF"/>
-                </a:solidFill>
-                <a:latin typeface="Arial" pitchFamily="34" charset="0"/>
-                <a:ea typeface="Arial" pitchFamily="34" charset="-122"/>
-                <a:cs typeface="Arial" pitchFamily="34" charset="-120"/>
-              </a:rPr>
-              <a:t>We will walk the valley with You by our side</a:t>
-            </a:r>
-            <a:endParaRPr lang="en-US" sz="4000" dirty="0"/>
-          </a:p>
-          <a:p>
-            <a:pPr algn="ctr" indent="0" marL="0">
-              <a:buNone/>
-            </a:pPr>
-            <a:r>
-              <a:rPr lang="en-US" sz="4000" b="1" dirty="0">
-                <a:solidFill>
-                  <a:srgbClr val="FFFFFF"/>
-                </a:solidFill>
-                <a:latin typeface="Arial" pitchFamily="34" charset="0"/>
-                <a:ea typeface="Arial" pitchFamily="34" charset="-122"/>
-                <a:cs typeface="Arial" pitchFamily="34" charset="-120"/>
-              </a:rPr>
-              <a:t>You will go before us, You will lead the way</a:t>
-            </a:r>
-            <a:endParaRPr lang="en-US" sz="4000" dirty="0"/>
-          </a:p>
-          <a:p>
-            <a:pPr algn="ctr" indent="0" marL="0">
-              <a:buNone/>
-            </a:pPr>
-            <a:r>
-              <a:rPr lang="en-US" sz="4000" b="1" dirty="0">
-                <a:solidFill>
-                  <a:srgbClr val="FFFFFF"/>
-                </a:solidFill>
-                <a:latin typeface="Arial" pitchFamily="34" charset="0"/>
-                <a:ea typeface="Arial" pitchFamily="34" charset="-122"/>
-                <a:cs typeface="Arial" pitchFamily="34" charset="-120"/>
-              </a:rPr>
-              <a:t>We have found a refuge, only You can save</a:t>
-            </a:r>
-            <a:endParaRPr lang="en-US" sz="4000" dirty="0"/>
+              <a:rPr lang="en-US" sz="4800" b="1" dirty="0">
+                <a:solidFill>
+                  <a:srgbClr val="FFFFFF"/>
+                </a:solidFill>
+                <a:latin typeface="Arial" pitchFamily="34" charset="0"/>
+                <a:ea typeface="Arial" pitchFamily="34" charset="-122"/>
+                <a:cs typeface="Arial" pitchFamily="34" charset="-120"/>
+              </a:rPr>
+              <a:t>God Is for Us</a:t>
+            </a:r>
+            <a:endParaRPr lang="en-US" sz="4800" dirty="0"/>
           </a:p>
         </p:txBody>
       </p:sp>
@@ -1556,68 +1594,68 @@
               <a:buNone/>
             </a:pPr>
             <a:r>
-              <a:rPr lang="en-US" sz="4000" b="1" i="1" dirty="0">
-                <a:solidFill>
-                  <a:srgbClr val="FFFFFF"/>
-                </a:solidFill>
-                <a:latin typeface="Arial" pitchFamily="34" charset="0"/>
-                <a:ea typeface="Arial" pitchFamily="34" charset="-122"/>
-                <a:cs typeface="Arial" pitchFamily="34" charset="-120"/>
-              </a:rPr>
-              <a:t>Sing with joy now: our God is for us.</a:t>
-            </a:r>
-            <a:endParaRPr lang="en-US" sz="4000" dirty="0"/>
-          </a:p>
-          <a:p>
-            <a:pPr algn="ctr" indent="0" marL="0">
-              <a:buNone/>
-            </a:pPr>
-            <a:r>
-              <a:rPr lang="en-US" sz="4000" b="1" i="1" dirty="0">
-                <a:solidFill>
-                  <a:srgbClr val="FFFFFF"/>
-                </a:solidFill>
-                <a:latin typeface="Arial" pitchFamily="34" charset="0"/>
-                <a:ea typeface="Arial" pitchFamily="34" charset="-122"/>
-                <a:cs typeface="Arial" pitchFamily="34" charset="-120"/>
-              </a:rPr>
-              <a:t>The Father's love is a strong and mighty fortress</a:t>
-            </a:r>
-            <a:endParaRPr lang="en-US" sz="4000" dirty="0"/>
-          </a:p>
-          <a:p>
-            <a:pPr algn="ctr" indent="0" marL="0">
-              <a:buNone/>
-            </a:pPr>
-            <a:r>
-              <a:rPr lang="en-US" sz="4000" b="1" i="1" dirty="0">
-                <a:solidFill>
-                  <a:srgbClr val="FFFFFF"/>
-                </a:solidFill>
-                <a:latin typeface="Arial" pitchFamily="34" charset="0"/>
-                <a:ea typeface="Arial" pitchFamily="34" charset="-122"/>
-                <a:cs typeface="Arial" pitchFamily="34" charset="-120"/>
-              </a:rPr>
-              <a:t>Raise your voice now, no love is greater.</a:t>
-            </a:r>
-            <a:endParaRPr lang="en-US" sz="4000" dirty="0"/>
-          </a:p>
-          <a:p>
-            <a:pPr algn="ctr" indent="0" marL="0">
-              <a:buNone/>
-            </a:pPr>
-            <a:r>
-              <a:rPr lang="en-US" sz="4000" b="1" i="1" dirty="0">
-                <a:solidFill>
-                  <a:srgbClr val="FFFFFF"/>
-                </a:solidFill>
-                <a:latin typeface="Arial" pitchFamily="34" charset="0"/>
-                <a:ea typeface="Arial" pitchFamily="34" charset="-122"/>
-                <a:cs typeface="Arial" pitchFamily="34" charset="-120"/>
-              </a:rPr>
-              <a:t>Who can stand against us if our God is for us</a:t>
-            </a:r>
-            <a:endParaRPr lang="en-US" sz="4000" dirty="0"/>
+              <a:rPr lang="en-US" sz="4800" b="1" dirty="0">
+                <a:solidFill>
+                  <a:srgbClr val="FFFFFF"/>
+                </a:solidFill>
+                <a:latin typeface="Arial" pitchFamily="34" charset="0"/>
+                <a:ea typeface="Arial" pitchFamily="34" charset="-122"/>
+                <a:cs typeface="Arial" pitchFamily="34" charset="-120"/>
+              </a:rPr>
+              <a:t>We won't fear the battle, we won’t fear the night</a:t>
+            </a:r>
+            <a:endParaRPr lang="en-US" sz="4800" dirty="0"/>
+          </a:p>
+          <a:p>
+            <a:pPr algn="ctr" indent="0" marL="0">
+              <a:buNone/>
+            </a:pPr>
+            <a:r>
+              <a:rPr lang="en-US" sz="4800" b="1" dirty="0">
+                <a:solidFill>
+                  <a:srgbClr val="FFFFFF"/>
+                </a:solidFill>
+                <a:latin typeface="Arial" pitchFamily="34" charset="0"/>
+                <a:ea typeface="Arial" pitchFamily="34" charset="-122"/>
+                <a:cs typeface="Arial" pitchFamily="34" charset="-120"/>
+              </a:rPr>
+              <a:t>We will walk the valley with You by our side</a:t>
+            </a:r>
+            <a:endParaRPr lang="en-US" sz="4800" dirty="0"/>
+          </a:p>
+          <a:p>
+            <a:pPr algn="ctr" indent="0" marL="0">
+              <a:buNone/>
+            </a:pPr>
+            <a:r>
+              <a:rPr lang="en-US" sz="4800" b="1" dirty="0">
+                <a:solidFill>
+                  <a:srgbClr val="FFFFFF"/>
+                </a:solidFill>
+                <a:latin typeface="Arial" pitchFamily="34" charset="0"/>
+                <a:ea typeface="Arial" pitchFamily="34" charset="-122"/>
+                <a:cs typeface="Arial" pitchFamily="34" charset="-120"/>
+              </a:rPr>
+              <a:t>You will go before us, You will lead the way</a:t>
+            </a:r>
+            <a:endParaRPr lang="en-US" sz="4800" dirty="0"/>
+          </a:p>
+          <a:p>
+            <a:pPr algn="ctr" indent="0" marL="0">
+              <a:buNone/>
+            </a:pPr>
+            <a:r>
+              <a:rPr lang="en-US" sz="4800" b="1" dirty="0">
+                <a:solidFill>
+                  <a:srgbClr val="FFFFFF"/>
+                </a:solidFill>
+                <a:latin typeface="Arial" pitchFamily="34" charset="0"/>
+                <a:ea typeface="Arial" pitchFamily="34" charset="-122"/>
+                <a:cs typeface="Arial" pitchFamily="34" charset="-120"/>
+              </a:rPr>
+              <a:t>We have found a refuge, only You can save</a:t>
+            </a:r>
+            <a:endParaRPr lang="en-US" sz="4800" dirty="0"/>
           </a:p>
         </p:txBody>
       </p:sp>
@@ -1678,68 +1716,68 @@
               <a:buNone/>
             </a:pPr>
             <a:r>
-              <a:rPr lang="en-US" sz="4000" b="1" dirty="0">
-                <a:solidFill>
-                  <a:srgbClr val="FFFFFF"/>
-                </a:solidFill>
-                <a:latin typeface="Arial" pitchFamily="34" charset="0"/>
-                <a:ea typeface="Arial" pitchFamily="34" charset="-122"/>
-                <a:cs typeface="Arial" pitchFamily="34" charset="-120"/>
-              </a:rPr>
-              <a:t>Even when I stumble, even when I fall</a:t>
-            </a:r>
-            <a:endParaRPr lang="en-US" sz="4000" dirty="0"/>
-          </a:p>
-          <a:p>
-            <a:pPr algn="ctr" indent="0" marL="0">
-              <a:buNone/>
-            </a:pPr>
-            <a:r>
-              <a:rPr lang="en-US" sz="4000" b="1" dirty="0">
-                <a:solidFill>
-                  <a:srgbClr val="FFFFFF"/>
-                </a:solidFill>
-                <a:latin typeface="Arial" pitchFamily="34" charset="0"/>
-                <a:ea typeface="Arial" pitchFamily="34" charset="-122"/>
-                <a:cs typeface="Arial" pitchFamily="34" charset="-120"/>
-              </a:rPr>
-              <a:t>Even when I turn back, still Your love is sure</a:t>
-            </a:r>
-            <a:endParaRPr lang="en-US" sz="4000" dirty="0"/>
-          </a:p>
-          <a:p>
-            <a:pPr algn="ctr" indent="0" marL="0">
-              <a:buNone/>
-            </a:pPr>
-            <a:r>
-              <a:rPr lang="en-US" sz="4000" b="1" dirty="0">
-                <a:solidFill>
-                  <a:srgbClr val="FFFFFF"/>
-                </a:solidFill>
-                <a:latin typeface="Arial" pitchFamily="34" charset="0"/>
-                <a:ea typeface="Arial" pitchFamily="34" charset="-122"/>
-                <a:cs typeface="Arial" pitchFamily="34" charset="-120"/>
-              </a:rPr>
-              <a:t>You will not abandon, You will not forsake</a:t>
-            </a:r>
-            <a:endParaRPr lang="en-US" sz="4000" dirty="0"/>
-          </a:p>
-          <a:p>
-            <a:pPr algn="ctr" indent="0" marL="0">
-              <a:buNone/>
-            </a:pPr>
-            <a:r>
-              <a:rPr lang="en-US" sz="4000" b="1" dirty="0">
-                <a:solidFill>
-                  <a:srgbClr val="FFFFFF"/>
-                </a:solidFill>
-                <a:latin typeface="Arial" pitchFamily="34" charset="0"/>
-                <a:ea typeface="Arial" pitchFamily="34" charset="-122"/>
-                <a:cs typeface="Arial" pitchFamily="34" charset="-120"/>
-              </a:rPr>
-              <a:t>You will carry me with never-ending grace</a:t>
-            </a:r>
-            <a:endParaRPr lang="en-US" sz="4000" dirty="0"/>
+              <a:rPr lang="en-US" sz="4800" b="1" i="1" dirty="0">
+                <a:solidFill>
+                  <a:srgbClr val="FFFFFF"/>
+                </a:solidFill>
+                <a:latin typeface="Arial" pitchFamily="34" charset="0"/>
+                <a:ea typeface="Arial" pitchFamily="34" charset="-122"/>
+                <a:cs typeface="Arial" pitchFamily="34" charset="-120"/>
+              </a:rPr>
+              <a:t>Sing with joy now: our God is for us.</a:t>
+            </a:r>
+            <a:endParaRPr lang="en-US" sz="4800" dirty="0"/>
+          </a:p>
+          <a:p>
+            <a:pPr algn="ctr" indent="0" marL="0">
+              <a:buNone/>
+            </a:pPr>
+            <a:r>
+              <a:rPr lang="en-US" sz="4800" b="1" i="1" dirty="0">
+                <a:solidFill>
+                  <a:srgbClr val="FFFFFF"/>
+                </a:solidFill>
+                <a:latin typeface="Arial" pitchFamily="34" charset="0"/>
+                <a:ea typeface="Arial" pitchFamily="34" charset="-122"/>
+                <a:cs typeface="Arial" pitchFamily="34" charset="-120"/>
+              </a:rPr>
+              <a:t>The Father's love is a strong and mighty fortress</a:t>
+            </a:r>
+            <a:endParaRPr lang="en-US" sz="4800" dirty="0"/>
+          </a:p>
+          <a:p>
+            <a:pPr algn="ctr" indent="0" marL="0">
+              <a:buNone/>
+            </a:pPr>
+            <a:r>
+              <a:rPr lang="en-US" sz="4800" b="1" i="1" dirty="0">
+                <a:solidFill>
+                  <a:srgbClr val="FFFFFF"/>
+                </a:solidFill>
+                <a:latin typeface="Arial" pitchFamily="34" charset="0"/>
+                <a:ea typeface="Arial" pitchFamily="34" charset="-122"/>
+                <a:cs typeface="Arial" pitchFamily="34" charset="-120"/>
+              </a:rPr>
+              <a:t>Raise your voice now, no love is greater.</a:t>
+            </a:r>
+            <a:endParaRPr lang="en-US" sz="4800" dirty="0"/>
+          </a:p>
+          <a:p>
+            <a:pPr algn="ctr" indent="0" marL="0">
+              <a:buNone/>
+            </a:pPr>
+            <a:r>
+              <a:rPr lang="en-US" sz="4800" b="1" i="1" dirty="0">
+                <a:solidFill>
+                  <a:srgbClr val="FFFFFF"/>
+                </a:solidFill>
+                <a:latin typeface="Arial" pitchFamily="34" charset="0"/>
+                <a:ea typeface="Arial" pitchFamily="34" charset="-122"/>
+                <a:cs typeface="Arial" pitchFamily="34" charset="-120"/>
+              </a:rPr>
+              <a:t>Who can stand against us if our God is for us</a:t>
+            </a:r>
+            <a:endParaRPr lang="en-US" sz="4800" dirty="0"/>
           </a:p>
         </p:txBody>
       </p:sp>
@@ -1800,68 +1838,68 @@
               <a:buNone/>
             </a:pPr>
             <a:r>
-              <a:rPr lang="en-US" sz="4000" b="1" i="1" dirty="0">
-                <a:solidFill>
-                  <a:srgbClr val="FFFFFF"/>
-                </a:solidFill>
-                <a:latin typeface="Arial" pitchFamily="34" charset="0"/>
-                <a:ea typeface="Arial" pitchFamily="34" charset="-122"/>
-                <a:cs typeface="Arial" pitchFamily="34" charset="-120"/>
-              </a:rPr>
-              <a:t>Sing with joy now: our God is for us.</a:t>
-            </a:r>
-            <a:endParaRPr lang="en-US" sz="4000" dirty="0"/>
-          </a:p>
-          <a:p>
-            <a:pPr algn="ctr" indent="0" marL="0">
-              <a:buNone/>
-            </a:pPr>
-            <a:r>
-              <a:rPr lang="en-US" sz="4000" b="1" i="1" dirty="0">
-                <a:solidFill>
-                  <a:srgbClr val="FFFFFF"/>
-                </a:solidFill>
-                <a:latin typeface="Arial" pitchFamily="34" charset="0"/>
-                <a:ea typeface="Arial" pitchFamily="34" charset="-122"/>
-                <a:cs typeface="Arial" pitchFamily="34" charset="-120"/>
-              </a:rPr>
-              <a:t>The Father's love is a strong and mighty fortress</a:t>
-            </a:r>
-            <a:endParaRPr lang="en-US" sz="4000" dirty="0"/>
-          </a:p>
-          <a:p>
-            <a:pPr algn="ctr" indent="0" marL="0">
-              <a:buNone/>
-            </a:pPr>
-            <a:r>
-              <a:rPr lang="en-US" sz="4000" b="1" i="1" dirty="0">
-                <a:solidFill>
-                  <a:srgbClr val="FFFFFF"/>
-                </a:solidFill>
-                <a:latin typeface="Arial" pitchFamily="34" charset="0"/>
-                <a:ea typeface="Arial" pitchFamily="34" charset="-122"/>
-                <a:cs typeface="Arial" pitchFamily="34" charset="-120"/>
-              </a:rPr>
-              <a:t>Raise your voice now, no love is greater.</a:t>
-            </a:r>
-            <a:endParaRPr lang="en-US" sz="4000" dirty="0"/>
-          </a:p>
-          <a:p>
-            <a:pPr algn="ctr" indent="0" marL="0">
-              <a:buNone/>
-            </a:pPr>
-            <a:r>
-              <a:rPr lang="en-US" sz="4000" b="1" i="1" dirty="0">
-                <a:solidFill>
-                  <a:srgbClr val="FFFFFF"/>
-                </a:solidFill>
-                <a:latin typeface="Arial" pitchFamily="34" charset="0"/>
-                <a:ea typeface="Arial" pitchFamily="34" charset="-122"/>
-                <a:cs typeface="Arial" pitchFamily="34" charset="-120"/>
-              </a:rPr>
-              <a:t>Who can stand against us if our God is for us</a:t>
-            </a:r>
-            <a:endParaRPr lang="en-US" sz="4000" dirty="0"/>
+              <a:rPr lang="en-US" sz="4800" b="1" dirty="0">
+                <a:solidFill>
+                  <a:srgbClr val="FFFFFF"/>
+                </a:solidFill>
+                <a:latin typeface="Arial" pitchFamily="34" charset="0"/>
+                <a:ea typeface="Arial" pitchFamily="34" charset="-122"/>
+                <a:cs typeface="Arial" pitchFamily="34" charset="-120"/>
+              </a:rPr>
+              <a:t>Even when I stumble, even when I fall</a:t>
+            </a:r>
+            <a:endParaRPr lang="en-US" sz="4800" dirty="0"/>
+          </a:p>
+          <a:p>
+            <a:pPr algn="ctr" indent="0" marL="0">
+              <a:buNone/>
+            </a:pPr>
+            <a:r>
+              <a:rPr lang="en-US" sz="4800" b="1" dirty="0">
+                <a:solidFill>
+                  <a:srgbClr val="FFFFFF"/>
+                </a:solidFill>
+                <a:latin typeface="Arial" pitchFamily="34" charset="0"/>
+                <a:ea typeface="Arial" pitchFamily="34" charset="-122"/>
+                <a:cs typeface="Arial" pitchFamily="34" charset="-120"/>
+              </a:rPr>
+              <a:t>Even when I turn back, still Your love is sure</a:t>
+            </a:r>
+            <a:endParaRPr lang="en-US" sz="4800" dirty="0"/>
+          </a:p>
+          <a:p>
+            <a:pPr algn="ctr" indent="0" marL="0">
+              <a:buNone/>
+            </a:pPr>
+            <a:r>
+              <a:rPr lang="en-US" sz="4800" b="1" dirty="0">
+                <a:solidFill>
+                  <a:srgbClr val="FFFFFF"/>
+                </a:solidFill>
+                <a:latin typeface="Arial" pitchFamily="34" charset="0"/>
+                <a:ea typeface="Arial" pitchFamily="34" charset="-122"/>
+                <a:cs typeface="Arial" pitchFamily="34" charset="-120"/>
+              </a:rPr>
+              <a:t>You will not abandon, You will not forsake</a:t>
+            </a:r>
+            <a:endParaRPr lang="en-US" sz="4800" dirty="0"/>
+          </a:p>
+          <a:p>
+            <a:pPr algn="ctr" indent="0" marL="0">
+              <a:buNone/>
+            </a:pPr>
+            <a:r>
+              <a:rPr lang="en-US" sz="4800" b="1" dirty="0">
+                <a:solidFill>
+                  <a:srgbClr val="FFFFFF"/>
+                </a:solidFill>
+                <a:latin typeface="Arial" pitchFamily="34" charset="0"/>
+                <a:ea typeface="Arial" pitchFamily="34" charset="-122"/>
+                <a:cs typeface="Arial" pitchFamily="34" charset="-120"/>
+              </a:rPr>
+              <a:t>You will carry me with never-ending grace</a:t>
+            </a:r>
+            <a:endParaRPr lang="en-US" sz="4800" dirty="0"/>
           </a:p>
         </p:txBody>
       </p:sp>
@@ -1922,68 +1960,68 @@
               <a:buNone/>
             </a:pPr>
             <a:r>
-              <a:rPr lang="en-US" sz="4000" b="1" dirty="0">
-                <a:solidFill>
-                  <a:srgbClr val="FFFFFF"/>
-                </a:solidFill>
-                <a:latin typeface="Arial" pitchFamily="34" charset="0"/>
-                <a:ea typeface="Arial" pitchFamily="34" charset="-122"/>
-                <a:cs typeface="Arial" pitchFamily="34" charset="-120"/>
-              </a:rPr>
-              <a:t>Neither height nor depth can separate us,</a:t>
-            </a:r>
-            <a:endParaRPr lang="en-US" sz="4000" dirty="0"/>
-          </a:p>
-          <a:p>
-            <a:pPr algn="ctr" indent="0" marL="0">
-              <a:buNone/>
-            </a:pPr>
-            <a:r>
-              <a:rPr lang="en-US" sz="4000" b="1" dirty="0">
-                <a:solidFill>
-                  <a:srgbClr val="FFFFFF"/>
-                </a:solidFill>
-                <a:latin typeface="Arial" pitchFamily="34" charset="0"/>
-                <a:ea typeface="Arial" pitchFamily="34" charset="-122"/>
-                <a:cs typeface="Arial" pitchFamily="34" charset="-120"/>
-              </a:rPr>
-              <a:t>Hell and death will not defeat us</a:t>
-            </a:r>
-            <a:endParaRPr lang="en-US" sz="4000" dirty="0"/>
-          </a:p>
-          <a:p>
-            <a:pPr algn="ctr" indent="0" marL="0">
-              <a:buNone/>
-            </a:pPr>
-            <a:r>
-              <a:rPr lang="en-US" sz="4000" b="1" dirty="0">
-                <a:solidFill>
-                  <a:srgbClr val="FFFFFF"/>
-                </a:solidFill>
-                <a:latin typeface="Arial" pitchFamily="34" charset="0"/>
-                <a:ea typeface="Arial" pitchFamily="34" charset="-122"/>
-                <a:cs typeface="Arial" pitchFamily="34" charset="-120"/>
-              </a:rPr>
-              <a:t>He who gave His son to free us,</a:t>
-            </a:r>
-            <a:endParaRPr lang="en-US" sz="4000" dirty="0"/>
-          </a:p>
-          <a:p>
-            <a:pPr algn="ctr" indent="0" marL="0">
-              <a:buNone/>
-            </a:pPr>
-            <a:r>
-              <a:rPr lang="en-US" sz="4000" b="1" dirty="0">
-                <a:solidFill>
-                  <a:srgbClr val="FFFFFF"/>
-                </a:solidFill>
-                <a:latin typeface="Arial" pitchFamily="34" charset="0"/>
-                <a:ea typeface="Arial" pitchFamily="34" charset="-122"/>
-                <a:cs typeface="Arial" pitchFamily="34" charset="-120"/>
-              </a:rPr>
-              <a:t>Holds me in His love</a:t>
-            </a:r>
-            <a:endParaRPr lang="en-US" sz="4000" dirty="0"/>
+              <a:rPr lang="en-US" sz="4800" b="1" i="1" dirty="0">
+                <a:solidFill>
+                  <a:srgbClr val="FFFFFF"/>
+                </a:solidFill>
+                <a:latin typeface="Arial" pitchFamily="34" charset="0"/>
+                <a:ea typeface="Arial" pitchFamily="34" charset="-122"/>
+                <a:cs typeface="Arial" pitchFamily="34" charset="-120"/>
+              </a:rPr>
+              <a:t>Sing with joy now: our God is for us.</a:t>
+            </a:r>
+            <a:endParaRPr lang="en-US" sz="4800" dirty="0"/>
+          </a:p>
+          <a:p>
+            <a:pPr algn="ctr" indent="0" marL="0">
+              <a:buNone/>
+            </a:pPr>
+            <a:r>
+              <a:rPr lang="en-US" sz="4800" b="1" i="1" dirty="0">
+                <a:solidFill>
+                  <a:srgbClr val="FFFFFF"/>
+                </a:solidFill>
+                <a:latin typeface="Arial" pitchFamily="34" charset="0"/>
+                <a:ea typeface="Arial" pitchFamily="34" charset="-122"/>
+                <a:cs typeface="Arial" pitchFamily="34" charset="-120"/>
+              </a:rPr>
+              <a:t>The Father's love is a strong and mighty fortress</a:t>
+            </a:r>
+            <a:endParaRPr lang="en-US" sz="4800" dirty="0"/>
+          </a:p>
+          <a:p>
+            <a:pPr algn="ctr" indent="0" marL="0">
+              <a:buNone/>
+            </a:pPr>
+            <a:r>
+              <a:rPr lang="en-US" sz="4800" b="1" i="1" dirty="0">
+                <a:solidFill>
+                  <a:srgbClr val="FFFFFF"/>
+                </a:solidFill>
+                <a:latin typeface="Arial" pitchFamily="34" charset="0"/>
+                <a:ea typeface="Arial" pitchFamily="34" charset="-122"/>
+                <a:cs typeface="Arial" pitchFamily="34" charset="-120"/>
+              </a:rPr>
+              <a:t>Raise your voice now, no love is greater.</a:t>
+            </a:r>
+            <a:endParaRPr lang="en-US" sz="4800" dirty="0"/>
+          </a:p>
+          <a:p>
+            <a:pPr algn="ctr" indent="0" marL="0">
+              <a:buNone/>
+            </a:pPr>
+            <a:r>
+              <a:rPr lang="en-US" sz="4800" b="1" i="1" dirty="0">
+                <a:solidFill>
+                  <a:srgbClr val="FFFFFF"/>
+                </a:solidFill>
+                <a:latin typeface="Arial" pitchFamily="34" charset="0"/>
+                <a:ea typeface="Arial" pitchFamily="34" charset="-122"/>
+                <a:cs typeface="Arial" pitchFamily="34" charset="-120"/>
+              </a:rPr>
+              <a:t>Who can stand against us if our God is for us</a:t>
+            </a:r>
+            <a:endParaRPr lang="en-US" sz="4800" dirty="0"/>
           </a:p>
         </p:txBody>
       </p:sp>
@@ -2044,7 +2082,7 @@
               <a:buNone/>
             </a:pPr>
             <a:r>
-              <a:rPr lang="en-US" sz="4000" b="1" dirty="0">
+              <a:rPr lang="en-US" sz="4800" b="1" dirty="0">
                 <a:solidFill>
                   <a:srgbClr val="FFFFFF"/>
                 </a:solidFill>
@@ -2054,14 +2092,14 @@
               </a:rPr>
               <a:t>Neither height nor depth can separate us,</a:t>
             </a:r>
-            <a:endParaRPr lang="en-US" sz="4000" dirty="0"/>
-          </a:p>
-          <a:p>
-            <a:pPr algn="ctr" indent="0" marL="0">
-              <a:buNone/>
-            </a:pPr>
-            <a:r>
-              <a:rPr lang="en-US" sz="4000" b="1" dirty="0">
+            <a:endParaRPr lang="en-US" sz="4800" dirty="0"/>
+          </a:p>
+          <a:p>
+            <a:pPr algn="ctr" indent="0" marL="0">
+              <a:buNone/>
+            </a:pPr>
+            <a:r>
+              <a:rPr lang="en-US" sz="4800" b="1" dirty="0">
                 <a:solidFill>
                   <a:srgbClr val="FFFFFF"/>
                 </a:solidFill>
@@ -2071,14 +2109,14 @@
               </a:rPr>
               <a:t>Hell and death will not defeat us</a:t>
             </a:r>
-            <a:endParaRPr lang="en-US" sz="4000" dirty="0"/>
-          </a:p>
-          <a:p>
-            <a:pPr algn="ctr" indent="0" marL="0">
-              <a:buNone/>
-            </a:pPr>
-            <a:r>
-              <a:rPr lang="en-US" sz="4000" b="1" dirty="0">
+            <a:endParaRPr lang="en-US" sz="4800" dirty="0"/>
+          </a:p>
+          <a:p>
+            <a:pPr algn="ctr" indent="0" marL="0">
+              <a:buNone/>
+            </a:pPr>
+            <a:r>
+              <a:rPr lang="en-US" sz="4800" b="1" dirty="0">
                 <a:solidFill>
                   <a:srgbClr val="FFFFFF"/>
                 </a:solidFill>
@@ -2088,14 +2126,14 @@
               </a:rPr>
               <a:t>He who gave His son to free us,</a:t>
             </a:r>
-            <a:endParaRPr lang="en-US" sz="4000" dirty="0"/>
-          </a:p>
-          <a:p>
-            <a:pPr algn="ctr" indent="0" marL="0">
-              <a:buNone/>
-            </a:pPr>
-            <a:r>
-              <a:rPr lang="en-US" sz="4000" b="1" dirty="0">
+            <a:endParaRPr lang="en-US" sz="4800" dirty="0"/>
+          </a:p>
+          <a:p>
+            <a:pPr algn="ctr" indent="0" marL="0">
+              <a:buNone/>
+            </a:pPr>
+            <a:r>
+              <a:rPr lang="en-US" sz="4800" b="1" dirty="0">
                 <a:solidFill>
                   <a:srgbClr val="FFFFFF"/>
                 </a:solidFill>
@@ -2105,7 +2143,7 @@
               </a:rPr>
               <a:t>Holds me in His love</a:t>
             </a:r>
-            <a:endParaRPr lang="en-US" sz="4000" dirty="0"/>
+            <a:endParaRPr lang="en-US" sz="4800" dirty="0"/>
           </a:p>
         </p:txBody>
       </p:sp>
@@ -2166,7 +2204,129 @@
               <a:buNone/>
             </a:pPr>
             <a:r>
-              <a:rPr lang="en-US" sz="4000" b="1" i="1" dirty="0">
+              <a:rPr lang="en-US" sz="4800" b="1" dirty="0">
+                <a:solidFill>
+                  <a:srgbClr val="FFFFFF"/>
+                </a:solidFill>
+                <a:latin typeface="Arial" pitchFamily="34" charset="0"/>
+                <a:ea typeface="Arial" pitchFamily="34" charset="-122"/>
+                <a:cs typeface="Arial" pitchFamily="34" charset="-120"/>
+              </a:rPr>
+              <a:t>Neither height nor depth can separate us,</a:t>
+            </a:r>
+            <a:endParaRPr lang="en-US" sz="4800" dirty="0"/>
+          </a:p>
+          <a:p>
+            <a:pPr algn="ctr" indent="0" marL="0">
+              <a:buNone/>
+            </a:pPr>
+            <a:r>
+              <a:rPr lang="en-US" sz="4800" b="1" dirty="0">
+                <a:solidFill>
+                  <a:srgbClr val="FFFFFF"/>
+                </a:solidFill>
+                <a:latin typeface="Arial" pitchFamily="34" charset="0"/>
+                <a:ea typeface="Arial" pitchFamily="34" charset="-122"/>
+                <a:cs typeface="Arial" pitchFamily="34" charset="-120"/>
+              </a:rPr>
+              <a:t>Hell and death will not defeat us</a:t>
+            </a:r>
+            <a:endParaRPr lang="en-US" sz="4800" dirty="0"/>
+          </a:p>
+          <a:p>
+            <a:pPr algn="ctr" indent="0" marL="0">
+              <a:buNone/>
+            </a:pPr>
+            <a:r>
+              <a:rPr lang="en-US" sz="4800" b="1" dirty="0">
+                <a:solidFill>
+                  <a:srgbClr val="FFFFFF"/>
+                </a:solidFill>
+                <a:latin typeface="Arial" pitchFamily="34" charset="0"/>
+                <a:ea typeface="Arial" pitchFamily="34" charset="-122"/>
+                <a:cs typeface="Arial" pitchFamily="34" charset="-120"/>
+              </a:rPr>
+              <a:t>He who gave His son to free us,</a:t>
+            </a:r>
+            <a:endParaRPr lang="en-US" sz="4800" dirty="0"/>
+          </a:p>
+          <a:p>
+            <a:pPr algn="ctr" indent="0" marL="0">
+              <a:buNone/>
+            </a:pPr>
+            <a:r>
+              <a:rPr lang="en-US" sz="4800" b="1" dirty="0">
+                <a:solidFill>
+                  <a:srgbClr val="FFFFFF"/>
+                </a:solidFill>
+                <a:latin typeface="Arial" pitchFamily="34" charset="0"/>
+                <a:ea typeface="Arial" pitchFamily="34" charset="-122"/>
+                <a:cs typeface="Arial" pitchFamily="34" charset="-120"/>
+              </a:rPr>
+              <a:t>Holds me in His love</a:t>
+            </a:r>
+            <a:endParaRPr lang="en-US" sz="4800" dirty="0"/>
+          </a:p>
+        </p:txBody>
+      </p:sp>
+    </p:spTree>
+  </p:cSld>
+  <p:clrMapOvr>
+    <a:masterClrMapping/>
+  </p:clrMapOvr>
+</p:sld>
+</file>
+
+<file path=ppt/slides/slide8.xml><?xml version="1.0" encoding="utf-8"?>
+<p:sld xmlns:a="http://schemas.openxmlformats.org/drawingml/2006/main" xmlns:r="http://schemas.openxmlformats.org/officeDocument/2006/relationships" xmlns:p="http://schemas.openxmlformats.org/presentationml/2006/main">
+  <p:cSld name="Slide 8">
+    <p:bg>
+      <p:bgPr>
+        <a:solidFill>
+          <a:srgbClr val="000000"/>
+        </a:solidFill>
+      </p:bgPr>
+    </p:bg>
+    <p:spTree>
+      <p:nvGrpSpPr>
+        <p:cNvPr id="1" name=""/>
+        <p:cNvGrpSpPr/>
+        <p:nvPr/>
+      </p:nvGrpSpPr>
+      <p:grpSpPr>
+        <a:xfrm>
+          <a:off x="0" y="0"/>
+          <a:ext cx="0" cy="0"/>
+          <a:chOff x="0" y="0"/>
+          <a:chExt cx="0" cy="0"/>
+        </a:xfrm>
+      </p:grpSpPr>
+      <p:sp>
+        <p:nvSpPr>
+          <p:cNvPr id="2" name="Text 0"/>
+          <p:cNvSpPr txBox="1"/>
+          <p:nvPr/>
+        </p:nvSpPr>
+        <p:spPr>
+          <a:xfrm>
+            <a:off x="548640" y="457200"/>
+            <a:ext cx="11064240" cy="5943600"/>
+          </a:xfrm>
+          <a:prstGeom prst="rect">
+            <a:avLst/>
+          </a:prstGeom>
+          <a:noFill/>
+          <a:ln/>
+        </p:spPr>
+        <p:txBody>
+          <a:bodyPr wrap="square" lIns="0" tIns="0" rIns="0" bIns="0" rtlCol="0" anchor="ctr"/>
+          <a:lstStyle/>
+          <a:p>
+            <a:pPr algn="ctr" indent="0" marL="0">
+              <a:buNone/>
+            </a:pPr>
+            <a:r>
+              <a:rPr lang="en-US" sz="4800" b="1" i="1" dirty="0">
                 <a:solidFill>
                   <a:srgbClr val="FFFFFF"/>
                 </a:solidFill>
@@ -2176,14 +2336,14 @@
               </a:rPr>
               <a:t>Sing with joy now: our God is for us.</a:t>
             </a:r>
-            <a:endParaRPr lang="en-US" sz="4000" dirty="0"/>
-          </a:p>
-          <a:p>
-            <a:pPr algn="ctr" indent="0" marL="0">
-              <a:buNone/>
-            </a:pPr>
-            <a:r>
-              <a:rPr lang="en-US" sz="4000" b="1" i="1" dirty="0">
+            <a:endParaRPr lang="en-US" sz="4800" dirty="0"/>
+          </a:p>
+          <a:p>
+            <a:pPr algn="ctr" indent="0" marL="0">
+              <a:buNone/>
+            </a:pPr>
+            <a:r>
+              <a:rPr lang="en-US" sz="4800" b="1" i="1" dirty="0">
                 <a:solidFill>
                   <a:srgbClr val="FFFFFF"/>
                 </a:solidFill>
@@ -2193,14 +2353,14 @@
               </a:rPr>
               <a:t>The Father's love is a strong and mighty fortress</a:t>
             </a:r>
-            <a:endParaRPr lang="en-US" sz="4000" dirty="0"/>
-          </a:p>
-          <a:p>
-            <a:pPr algn="ctr" indent="0" marL="0">
-              <a:buNone/>
-            </a:pPr>
-            <a:r>
-              <a:rPr lang="en-US" sz="4000" b="1" i="1" dirty="0">
+            <a:endParaRPr lang="en-US" sz="4800" dirty="0"/>
+          </a:p>
+          <a:p>
+            <a:pPr algn="ctr" indent="0" marL="0">
+              <a:buNone/>
+            </a:pPr>
+            <a:r>
+              <a:rPr lang="en-US" sz="4800" b="1" i="1" dirty="0">
                 <a:solidFill>
                   <a:srgbClr val="FFFFFF"/>
                 </a:solidFill>
@@ -2210,14 +2370,14 @@
               </a:rPr>
               <a:t>Raise your voice now, no love is greater.</a:t>
             </a:r>
-            <a:endParaRPr lang="en-US" sz="4000" dirty="0"/>
-          </a:p>
-          <a:p>
-            <a:pPr algn="ctr" indent="0" marL="0">
-              <a:buNone/>
-            </a:pPr>
-            <a:r>
-              <a:rPr lang="en-US" sz="4000" b="1" i="1" dirty="0">
+            <a:endParaRPr lang="en-US" sz="4800" dirty="0"/>
+          </a:p>
+          <a:p>
+            <a:pPr algn="ctr" indent="0" marL="0">
+              <a:buNone/>
+            </a:pPr>
+            <a:r>
+              <a:rPr lang="en-US" sz="4800" b="1" i="1" dirty="0">
                 <a:solidFill>
                   <a:srgbClr val="FFFFFF"/>
                 </a:solidFill>
@@ -2227,14 +2387,14 @@
               </a:rPr>
               <a:t>Who can stand against us if our God is for us</a:t>
             </a:r>
-            <a:endParaRPr lang="en-US" sz="4000" dirty="0"/>
-          </a:p>
-          <a:p>
-            <a:pPr algn="ctr" indent="0" marL="0">
-              <a:buNone/>
-            </a:pPr>
-            <a:r>
-              <a:rPr lang="en-US" sz="4000" b="1" i="1" dirty="0">
+            <a:endParaRPr lang="en-US" sz="4800" dirty="0"/>
+          </a:p>
+          <a:p>
+            <a:pPr algn="ctr" indent="0" marL="0">
+              <a:buNone/>
+            </a:pPr>
+            <a:r>
+              <a:rPr lang="en-US" sz="4800" b="1" i="1" dirty="0">
                 <a:solidFill>
                   <a:srgbClr val="FFFFFF"/>
                 </a:solidFill>
@@ -2244,7 +2404,7 @@
               </a:rPr>
               <a:t>***</a:t>
             </a:r>
-            <a:endParaRPr lang="en-US" sz="4000" dirty="0"/>
+            <a:endParaRPr lang="en-US" sz="4800" dirty="0"/>
           </a:p>
         </p:txBody>
       </p:sp>

</xml_diff>

<commit_message>
Update PowerPoint for song #3 in FUBC - English
</commit_message>
<xml_diff>
--- a/fubc-en/3-God Is for Us.pptx
+++ b/fubc-en/3-God Is for Us.pptx
@@ -13,9 +13,14 @@
     <p:sldId id="261" r:id="rId7"/>
     <p:sldId id="262" r:id="rId8"/>
     <p:sldId id="263" r:id="rId9"/>
+    <p:sldId id="264" r:id="rId10"/>
+    <p:sldId id="265" r:id="rId11"/>
+    <p:sldId id="266" r:id="rId12"/>
+    <p:sldId id="267" r:id="rId13"/>
+    <p:sldId id="268" r:id="rId14"/>
   </p:sldIdLst>
   <p:notesMasterIdLst>
-    <p:notesMasterId r:id="rId10"/>
+    <p:notesMasterId r:id="rId15"/>
   </p:notesMasterIdLst>
   <p:sldSz cx="12192000" cy="6858000"/>
   <p:notesSz cx="6858000" cy="12192000"/>
@@ -551,6 +556,358 @@
 </p:notes>
 </file>
 
+<file path=ppt/notesSlides/notesSlide10.xml><?xml version="1.0" encoding="utf-8"?>
+<p:notes xmlns:a="http://schemas.openxmlformats.org/drawingml/2006/main" xmlns:r="http://schemas.openxmlformats.org/officeDocument/2006/relationships" xmlns:p="http://schemas.openxmlformats.org/presentationml/2006/main">
+  <p:cSld>
+    <p:spTree>
+      <p:nvGrpSpPr>
+        <p:cNvPr id="1" name=""/>
+        <p:cNvGrpSpPr/>
+        <p:nvPr/>
+      </p:nvGrpSpPr>
+      <p:grpSpPr>
+        <a:xfrm>
+          <a:off x="0" y="0"/>
+          <a:ext cx="0" cy="0"/>
+          <a:chOff x="0" y="0"/>
+          <a:chExt cx="0" cy="0"/>
+        </a:xfrm>
+      </p:grpSpPr>
+      <p:sp>
+        <p:nvSpPr>
+          <p:cNvPr id="2" name="Slide Image Placeholder 1"/>
+          <p:cNvSpPr>
+            <a:spLocks noGrp="1" noRot="1" noChangeAspect="1"/>
+          </p:cNvSpPr>
+          <p:nvPr>
+            <p:ph type="sldImg"/>
+          </p:nvPr>
+        </p:nvSpPr>
+        <p:spPr/>
+      </p:sp>
+      <p:sp>
+        <p:nvSpPr>
+          <p:cNvPr id="3" name="Notes Placeholder 2"/>
+          <p:cNvSpPr>
+            <a:spLocks noGrp="1"/>
+          </p:cNvSpPr>
+          <p:nvPr>
+            <p:ph type="body" idx="1"/>
+          </p:nvPr>
+        </p:nvSpPr>
+        <p:spPr/>
+        <p:txBody>
+          <a:bodyPr/>
+          <a:lstStyle/>
+          <a:p>
+            <a:r>
+              <a:rPr lang="en-US" dirty="0"/>
+              <a:t/>
+            </a:r>
+            <a:endParaRPr lang="en-US" dirty="0"/>
+          </a:p>
+        </p:txBody>
+      </p:sp>
+      <p:sp>
+        <p:nvSpPr>
+          <p:cNvPr id="4" name="Slide Number Placeholder 3"/>
+          <p:cNvSpPr>
+            <a:spLocks noGrp="1"/>
+          </p:cNvSpPr>
+          <p:nvPr>
+            <p:ph type="sldNum" sz="quarter" idx="10"/>
+          </p:nvPr>
+        </p:nvSpPr>
+        <p:spPr/>
+        <p:txBody>
+          <a:bodyPr/>
+          <a:lstStyle/>
+          <a:p>
+            <a:fld id="{F7021451-1387-4CA6-816F-3879F97B5CBC}" type="slidenum">
+              <a:rPr lang="en-US"/>
+              <a:t>10</a:t>
+            </a:fld>
+            <a:endParaRPr lang="en-US"/>
+          </a:p>
+        </p:txBody>
+      </p:sp>
+    </p:spTree>
+    <p:extLst>
+      <p:ext uri="{BB962C8B-B14F-4D97-AF65-F5344CB8AC3E}">
+        <p14:creationId xmlns:p14="http://schemas.microsoft.com/office/powerpoint/2010/main" val="1024086991"/>
+      </p:ext>
+    </p:extLst>
+  </p:cSld>
+  <p:clrMapOvr>
+    <a:masterClrMapping/>
+  </p:clrMapOvr>
+</p:notes>
+</file>
+
+<file path=ppt/notesSlides/notesSlide11.xml><?xml version="1.0" encoding="utf-8"?>
+<p:notes xmlns:a="http://schemas.openxmlformats.org/drawingml/2006/main" xmlns:r="http://schemas.openxmlformats.org/officeDocument/2006/relationships" xmlns:p="http://schemas.openxmlformats.org/presentationml/2006/main">
+  <p:cSld>
+    <p:spTree>
+      <p:nvGrpSpPr>
+        <p:cNvPr id="1" name=""/>
+        <p:cNvGrpSpPr/>
+        <p:nvPr/>
+      </p:nvGrpSpPr>
+      <p:grpSpPr>
+        <a:xfrm>
+          <a:off x="0" y="0"/>
+          <a:ext cx="0" cy="0"/>
+          <a:chOff x="0" y="0"/>
+          <a:chExt cx="0" cy="0"/>
+        </a:xfrm>
+      </p:grpSpPr>
+      <p:sp>
+        <p:nvSpPr>
+          <p:cNvPr id="2" name="Slide Image Placeholder 1"/>
+          <p:cNvSpPr>
+            <a:spLocks noGrp="1" noRot="1" noChangeAspect="1"/>
+          </p:cNvSpPr>
+          <p:nvPr>
+            <p:ph type="sldImg"/>
+          </p:nvPr>
+        </p:nvSpPr>
+        <p:spPr/>
+      </p:sp>
+      <p:sp>
+        <p:nvSpPr>
+          <p:cNvPr id="3" name="Notes Placeholder 2"/>
+          <p:cNvSpPr>
+            <a:spLocks noGrp="1"/>
+          </p:cNvSpPr>
+          <p:nvPr>
+            <p:ph type="body" idx="1"/>
+          </p:nvPr>
+        </p:nvSpPr>
+        <p:spPr/>
+        <p:txBody>
+          <a:bodyPr/>
+          <a:lstStyle/>
+          <a:p>
+            <a:r>
+              <a:rPr lang="en-US" dirty="0"/>
+              <a:t/>
+            </a:r>
+            <a:endParaRPr lang="en-US" dirty="0"/>
+          </a:p>
+        </p:txBody>
+      </p:sp>
+      <p:sp>
+        <p:nvSpPr>
+          <p:cNvPr id="4" name="Slide Number Placeholder 3"/>
+          <p:cNvSpPr>
+            <a:spLocks noGrp="1"/>
+          </p:cNvSpPr>
+          <p:nvPr>
+            <p:ph type="sldNum" sz="quarter" idx="10"/>
+          </p:nvPr>
+        </p:nvSpPr>
+        <p:spPr/>
+        <p:txBody>
+          <a:bodyPr/>
+          <a:lstStyle/>
+          <a:p>
+            <a:fld id="{F7021451-1387-4CA6-816F-3879F97B5CBC}" type="slidenum">
+              <a:rPr lang="en-US"/>
+              <a:t>11</a:t>
+            </a:fld>
+            <a:endParaRPr lang="en-US"/>
+          </a:p>
+        </p:txBody>
+      </p:sp>
+    </p:spTree>
+    <p:extLst>
+      <p:ext uri="{BB962C8B-B14F-4D97-AF65-F5344CB8AC3E}">
+        <p14:creationId xmlns:p14="http://schemas.microsoft.com/office/powerpoint/2010/main" val="1024086991"/>
+      </p:ext>
+    </p:extLst>
+  </p:cSld>
+  <p:clrMapOvr>
+    <a:masterClrMapping/>
+  </p:clrMapOvr>
+</p:notes>
+</file>
+
+<file path=ppt/notesSlides/notesSlide12.xml><?xml version="1.0" encoding="utf-8"?>
+<p:notes xmlns:a="http://schemas.openxmlformats.org/drawingml/2006/main" xmlns:r="http://schemas.openxmlformats.org/officeDocument/2006/relationships" xmlns:p="http://schemas.openxmlformats.org/presentationml/2006/main">
+  <p:cSld>
+    <p:spTree>
+      <p:nvGrpSpPr>
+        <p:cNvPr id="1" name=""/>
+        <p:cNvGrpSpPr/>
+        <p:nvPr/>
+      </p:nvGrpSpPr>
+      <p:grpSpPr>
+        <a:xfrm>
+          <a:off x="0" y="0"/>
+          <a:ext cx="0" cy="0"/>
+          <a:chOff x="0" y="0"/>
+          <a:chExt cx="0" cy="0"/>
+        </a:xfrm>
+      </p:grpSpPr>
+      <p:sp>
+        <p:nvSpPr>
+          <p:cNvPr id="2" name="Slide Image Placeholder 1"/>
+          <p:cNvSpPr>
+            <a:spLocks noGrp="1" noRot="1" noChangeAspect="1"/>
+          </p:cNvSpPr>
+          <p:nvPr>
+            <p:ph type="sldImg"/>
+          </p:nvPr>
+        </p:nvSpPr>
+        <p:spPr/>
+      </p:sp>
+      <p:sp>
+        <p:nvSpPr>
+          <p:cNvPr id="3" name="Notes Placeholder 2"/>
+          <p:cNvSpPr>
+            <a:spLocks noGrp="1"/>
+          </p:cNvSpPr>
+          <p:nvPr>
+            <p:ph type="body" idx="1"/>
+          </p:nvPr>
+        </p:nvSpPr>
+        <p:spPr/>
+        <p:txBody>
+          <a:bodyPr/>
+          <a:lstStyle/>
+          <a:p>
+            <a:r>
+              <a:rPr lang="en-US" dirty="0"/>
+              <a:t/>
+            </a:r>
+            <a:endParaRPr lang="en-US" dirty="0"/>
+          </a:p>
+        </p:txBody>
+      </p:sp>
+      <p:sp>
+        <p:nvSpPr>
+          <p:cNvPr id="4" name="Slide Number Placeholder 3"/>
+          <p:cNvSpPr>
+            <a:spLocks noGrp="1"/>
+          </p:cNvSpPr>
+          <p:nvPr>
+            <p:ph type="sldNum" sz="quarter" idx="10"/>
+          </p:nvPr>
+        </p:nvSpPr>
+        <p:spPr/>
+        <p:txBody>
+          <a:bodyPr/>
+          <a:lstStyle/>
+          <a:p>
+            <a:fld id="{F7021451-1387-4CA6-816F-3879F97B5CBC}" type="slidenum">
+              <a:rPr lang="en-US"/>
+              <a:t>12</a:t>
+            </a:fld>
+            <a:endParaRPr lang="en-US"/>
+          </a:p>
+        </p:txBody>
+      </p:sp>
+    </p:spTree>
+    <p:extLst>
+      <p:ext uri="{BB962C8B-B14F-4D97-AF65-F5344CB8AC3E}">
+        <p14:creationId xmlns:p14="http://schemas.microsoft.com/office/powerpoint/2010/main" val="1024086991"/>
+      </p:ext>
+    </p:extLst>
+  </p:cSld>
+  <p:clrMapOvr>
+    <a:masterClrMapping/>
+  </p:clrMapOvr>
+</p:notes>
+</file>
+
+<file path=ppt/notesSlides/notesSlide13.xml><?xml version="1.0" encoding="utf-8"?>
+<p:notes xmlns:a="http://schemas.openxmlformats.org/drawingml/2006/main" xmlns:r="http://schemas.openxmlformats.org/officeDocument/2006/relationships" xmlns:p="http://schemas.openxmlformats.org/presentationml/2006/main">
+  <p:cSld>
+    <p:spTree>
+      <p:nvGrpSpPr>
+        <p:cNvPr id="1" name=""/>
+        <p:cNvGrpSpPr/>
+        <p:nvPr/>
+      </p:nvGrpSpPr>
+      <p:grpSpPr>
+        <a:xfrm>
+          <a:off x="0" y="0"/>
+          <a:ext cx="0" cy="0"/>
+          <a:chOff x="0" y="0"/>
+          <a:chExt cx="0" cy="0"/>
+        </a:xfrm>
+      </p:grpSpPr>
+      <p:sp>
+        <p:nvSpPr>
+          <p:cNvPr id="2" name="Slide Image Placeholder 1"/>
+          <p:cNvSpPr>
+            <a:spLocks noGrp="1" noRot="1" noChangeAspect="1"/>
+          </p:cNvSpPr>
+          <p:nvPr>
+            <p:ph type="sldImg"/>
+          </p:nvPr>
+        </p:nvSpPr>
+        <p:spPr/>
+      </p:sp>
+      <p:sp>
+        <p:nvSpPr>
+          <p:cNvPr id="3" name="Notes Placeholder 2"/>
+          <p:cNvSpPr>
+            <a:spLocks noGrp="1"/>
+          </p:cNvSpPr>
+          <p:nvPr>
+            <p:ph type="body" idx="1"/>
+          </p:nvPr>
+        </p:nvSpPr>
+        <p:spPr/>
+        <p:txBody>
+          <a:bodyPr/>
+          <a:lstStyle/>
+          <a:p>
+            <a:r>
+              <a:rPr lang="en-US" dirty="0"/>
+              <a:t/>
+            </a:r>
+            <a:endParaRPr lang="en-US" dirty="0"/>
+          </a:p>
+        </p:txBody>
+      </p:sp>
+      <p:sp>
+        <p:nvSpPr>
+          <p:cNvPr id="4" name="Slide Number Placeholder 3"/>
+          <p:cNvSpPr>
+            <a:spLocks noGrp="1"/>
+          </p:cNvSpPr>
+          <p:nvPr>
+            <p:ph type="sldNum" sz="quarter" idx="10"/>
+          </p:nvPr>
+        </p:nvSpPr>
+        <p:spPr/>
+        <p:txBody>
+          <a:bodyPr/>
+          <a:lstStyle/>
+          <a:p>
+            <a:fld id="{F7021451-1387-4CA6-816F-3879F97B5CBC}" type="slidenum">
+              <a:rPr lang="en-US"/>
+              <a:t>13</a:t>
+            </a:fld>
+            <a:endParaRPr lang="en-US"/>
+          </a:p>
+        </p:txBody>
+      </p:sp>
+    </p:spTree>
+    <p:extLst>
+      <p:ext uri="{BB962C8B-B14F-4D97-AF65-F5344CB8AC3E}">
+        <p14:creationId xmlns:p14="http://schemas.microsoft.com/office/powerpoint/2010/main" val="1024086991"/>
+      </p:ext>
+    </p:extLst>
+  </p:cSld>
+  <p:clrMapOvr>
+    <a:masterClrMapping/>
+  </p:clrMapOvr>
+</p:notes>
+</file>
+
 <file path=ppt/notesSlides/notesSlide2.xml><?xml version="1.0" encoding="utf-8"?>
 <p:notes xmlns:a="http://schemas.openxmlformats.org/drawingml/2006/main" xmlns:r="http://schemas.openxmlformats.org/officeDocument/2006/relationships" xmlns:p="http://schemas.openxmlformats.org/presentationml/2006/main">
   <p:cSld>
@@ -1149,6 +1506,94 @@
             <a:fld id="{F7021451-1387-4CA6-816F-3879F97B5CBC}" type="slidenum">
               <a:rPr lang="en-US"/>
               <a:t>8</a:t>
+            </a:fld>
+            <a:endParaRPr lang="en-US"/>
+          </a:p>
+        </p:txBody>
+      </p:sp>
+    </p:spTree>
+    <p:extLst>
+      <p:ext uri="{BB962C8B-B14F-4D97-AF65-F5344CB8AC3E}">
+        <p14:creationId xmlns:p14="http://schemas.microsoft.com/office/powerpoint/2010/main" val="1024086991"/>
+      </p:ext>
+    </p:extLst>
+  </p:cSld>
+  <p:clrMapOvr>
+    <a:masterClrMapping/>
+  </p:clrMapOvr>
+</p:notes>
+</file>
+
+<file path=ppt/notesSlides/notesSlide9.xml><?xml version="1.0" encoding="utf-8"?>
+<p:notes xmlns:a="http://schemas.openxmlformats.org/drawingml/2006/main" xmlns:r="http://schemas.openxmlformats.org/officeDocument/2006/relationships" xmlns:p="http://schemas.openxmlformats.org/presentationml/2006/main">
+  <p:cSld>
+    <p:spTree>
+      <p:nvGrpSpPr>
+        <p:cNvPr id="1" name=""/>
+        <p:cNvGrpSpPr/>
+        <p:nvPr/>
+      </p:nvGrpSpPr>
+      <p:grpSpPr>
+        <a:xfrm>
+          <a:off x="0" y="0"/>
+          <a:ext cx="0" cy="0"/>
+          <a:chOff x="0" y="0"/>
+          <a:chExt cx="0" cy="0"/>
+        </a:xfrm>
+      </p:grpSpPr>
+      <p:sp>
+        <p:nvSpPr>
+          <p:cNvPr id="2" name="Slide Image Placeholder 1"/>
+          <p:cNvSpPr>
+            <a:spLocks noGrp="1" noRot="1" noChangeAspect="1"/>
+          </p:cNvSpPr>
+          <p:nvPr>
+            <p:ph type="sldImg"/>
+          </p:nvPr>
+        </p:nvSpPr>
+        <p:spPr/>
+      </p:sp>
+      <p:sp>
+        <p:nvSpPr>
+          <p:cNvPr id="3" name="Notes Placeholder 2"/>
+          <p:cNvSpPr>
+            <a:spLocks noGrp="1"/>
+          </p:cNvSpPr>
+          <p:nvPr>
+            <p:ph type="body" idx="1"/>
+          </p:nvPr>
+        </p:nvSpPr>
+        <p:spPr/>
+        <p:txBody>
+          <a:bodyPr/>
+          <a:lstStyle/>
+          <a:p>
+            <a:r>
+              <a:rPr lang="en-US" dirty="0"/>
+              <a:t/>
+            </a:r>
+            <a:endParaRPr lang="en-US" dirty="0"/>
+          </a:p>
+        </p:txBody>
+      </p:sp>
+      <p:sp>
+        <p:nvSpPr>
+          <p:cNvPr id="4" name="Slide Number Placeholder 3"/>
+          <p:cNvSpPr>
+            <a:spLocks noGrp="1"/>
+          </p:cNvSpPr>
+          <p:nvPr>
+            <p:ph type="sldNum" sz="quarter" idx="10"/>
+          </p:nvPr>
+        </p:nvSpPr>
+        <p:spPr/>
+        <p:txBody>
+          <a:bodyPr/>
+          <a:lstStyle/>
+          <a:p>
+            <a:fld id="{F7021451-1387-4CA6-816F-3879F97B5CBC}" type="slidenum">
+              <a:rPr lang="en-US"/>
+              <a:t>9</a:t>
             </a:fld>
             <a:endParaRPr lang="en-US"/>
           </a:p>
@@ -1545,6 +1990,517 @@
 </p:sld>
 </file>
 
+<file path=ppt/slides/slide10.xml><?xml version="1.0" encoding="utf-8"?>
+<p:sld xmlns:a="http://schemas.openxmlformats.org/drawingml/2006/main" xmlns:r="http://schemas.openxmlformats.org/officeDocument/2006/relationships" xmlns:p="http://schemas.openxmlformats.org/presentationml/2006/main">
+  <p:cSld name="Slide 10">
+    <p:bg>
+      <p:bgPr>
+        <a:solidFill>
+          <a:srgbClr val="000000"/>
+        </a:solidFill>
+      </p:bgPr>
+    </p:bg>
+    <p:spTree>
+      <p:nvGrpSpPr>
+        <p:cNvPr id="1" name=""/>
+        <p:cNvGrpSpPr/>
+        <p:nvPr/>
+      </p:nvGrpSpPr>
+      <p:grpSpPr>
+        <a:xfrm>
+          <a:off x="0" y="0"/>
+          <a:ext cx="0" cy="0"/>
+          <a:chOff x="0" y="0"/>
+          <a:chExt cx="0" cy="0"/>
+        </a:xfrm>
+      </p:grpSpPr>
+      <p:sp>
+        <p:nvSpPr>
+          <p:cNvPr id="2" name="Text 0"/>
+          <p:cNvSpPr txBox="1"/>
+          <p:nvPr/>
+        </p:nvSpPr>
+        <p:spPr>
+          <a:xfrm>
+            <a:off x="548640" y="457200"/>
+            <a:ext cx="11064240" cy="5943600"/>
+          </a:xfrm>
+          <a:prstGeom prst="rect">
+            <a:avLst/>
+          </a:prstGeom>
+          <a:noFill/>
+          <a:ln/>
+        </p:spPr>
+        <p:txBody>
+          <a:bodyPr wrap="square" lIns="0" tIns="0" rIns="0" bIns="0" rtlCol="0" anchor="ctr"/>
+          <a:lstStyle/>
+          <a:p>
+            <a:pPr algn="ctr" indent="0" marL="0">
+              <a:buNone/>
+            </a:pPr>
+            <a:r>
+              <a:rPr lang="en-US" sz="4800" b="1" dirty="0">
+                <a:solidFill>
+                  <a:srgbClr val="FFFFFF"/>
+                </a:solidFill>
+                <a:latin typeface="Arial" pitchFamily="34" charset="0"/>
+                <a:ea typeface="Arial" pitchFamily="34" charset="-122"/>
+                <a:cs typeface="Arial" pitchFamily="34" charset="-120"/>
+              </a:rPr>
+              <a:t>Neither height nor depth can separate us,</a:t>
+            </a:r>
+            <a:endParaRPr lang="en-US" sz="4800" dirty="0"/>
+          </a:p>
+          <a:p>
+            <a:pPr algn="ctr" indent="0" marL="0">
+              <a:buNone/>
+            </a:pPr>
+            <a:r>
+              <a:rPr lang="en-US" sz="4800" b="1" dirty="0">
+                <a:solidFill>
+                  <a:srgbClr val="FFFFFF"/>
+                </a:solidFill>
+                <a:latin typeface="Arial" pitchFamily="34" charset="0"/>
+                <a:ea typeface="Arial" pitchFamily="34" charset="-122"/>
+                <a:cs typeface="Arial" pitchFamily="34" charset="-120"/>
+              </a:rPr>
+              <a:t>Hell and death will not defeat us</a:t>
+            </a:r>
+            <a:endParaRPr lang="en-US" sz="4800" dirty="0"/>
+          </a:p>
+          <a:p>
+            <a:pPr algn="ctr" indent="0" marL="0">
+              <a:buNone/>
+            </a:pPr>
+            <a:r>
+              <a:rPr lang="en-US" sz="4800" b="1" dirty="0">
+                <a:solidFill>
+                  <a:srgbClr val="FFFFFF"/>
+                </a:solidFill>
+                <a:latin typeface="Arial" pitchFamily="34" charset="0"/>
+                <a:ea typeface="Arial" pitchFamily="34" charset="-122"/>
+                <a:cs typeface="Arial" pitchFamily="34" charset="-120"/>
+              </a:rPr>
+              <a:t>He who gave His son to free us,</a:t>
+            </a:r>
+            <a:endParaRPr lang="en-US" sz="4800" dirty="0"/>
+          </a:p>
+          <a:p>
+            <a:pPr algn="ctr" indent="0" marL="0">
+              <a:buNone/>
+            </a:pPr>
+            <a:r>
+              <a:rPr lang="en-US" sz="4800" b="1" dirty="0">
+                <a:solidFill>
+                  <a:srgbClr val="FFFFFF"/>
+                </a:solidFill>
+                <a:latin typeface="Arial" pitchFamily="34" charset="0"/>
+                <a:ea typeface="Arial" pitchFamily="34" charset="-122"/>
+                <a:cs typeface="Arial" pitchFamily="34" charset="-120"/>
+              </a:rPr>
+              <a:t>Holds me in His love</a:t>
+            </a:r>
+            <a:endParaRPr lang="en-US" sz="4800" dirty="0"/>
+          </a:p>
+        </p:txBody>
+      </p:sp>
+    </p:spTree>
+  </p:cSld>
+  <p:clrMapOvr>
+    <a:masterClrMapping/>
+  </p:clrMapOvr>
+</p:sld>
+</file>
+
+<file path=ppt/slides/slide11.xml><?xml version="1.0" encoding="utf-8"?>
+<p:sld xmlns:a="http://schemas.openxmlformats.org/drawingml/2006/main" xmlns:r="http://schemas.openxmlformats.org/officeDocument/2006/relationships" xmlns:p="http://schemas.openxmlformats.org/presentationml/2006/main">
+  <p:cSld name="Slide 11">
+    <p:bg>
+      <p:bgPr>
+        <a:solidFill>
+          <a:srgbClr val="000000"/>
+        </a:solidFill>
+      </p:bgPr>
+    </p:bg>
+    <p:spTree>
+      <p:nvGrpSpPr>
+        <p:cNvPr id="1" name=""/>
+        <p:cNvGrpSpPr/>
+        <p:nvPr/>
+      </p:nvGrpSpPr>
+      <p:grpSpPr>
+        <a:xfrm>
+          <a:off x="0" y="0"/>
+          <a:ext cx="0" cy="0"/>
+          <a:chOff x="0" y="0"/>
+          <a:chExt cx="0" cy="0"/>
+        </a:xfrm>
+      </p:grpSpPr>
+      <p:sp>
+        <p:nvSpPr>
+          <p:cNvPr id="2" name="Text 0"/>
+          <p:cNvSpPr txBox="1"/>
+          <p:nvPr/>
+        </p:nvSpPr>
+        <p:spPr>
+          <a:xfrm>
+            <a:off x="548640" y="457200"/>
+            <a:ext cx="11064240" cy="5943600"/>
+          </a:xfrm>
+          <a:prstGeom prst="rect">
+            <a:avLst/>
+          </a:prstGeom>
+          <a:noFill/>
+          <a:ln/>
+        </p:spPr>
+        <p:txBody>
+          <a:bodyPr wrap="square" lIns="0" tIns="0" rIns="0" bIns="0" rtlCol="0" anchor="ctr"/>
+          <a:lstStyle/>
+          <a:p>
+            <a:pPr algn="ctr" indent="0" marL="0">
+              <a:buNone/>
+            </a:pPr>
+            <a:r>
+              <a:rPr lang="en-US" sz="4800" b="1" dirty="0">
+                <a:solidFill>
+                  <a:srgbClr val="FFFFFF"/>
+                </a:solidFill>
+                <a:latin typeface="Arial" pitchFamily="34" charset="0"/>
+                <a:ea typeface="Arial" pitchFamily="34" charset="-122"/>
+                <a:cs typeface="Arial" pitchFamily="34" charset="-120"/>
+              </a:rPr>
+              <a:t>Neither height nor depth can separate us,</a:t>
+            </a:r>
+            <a:endParaRPr lang="en-US" sz="4800" dirty="0"/>
+          </a:p>
+          <a:p>
+            <a:pPr algn="ctr" indent="0" marL="0">
+              <a:buNone/>
+            </a:pPr>
+            <a:r>
+              <a:rPr lang="en-US" sz="4800" b="1" dirty="0">
+                <a:solidFill>
+                  <a:srgbClr val="FFFFFF"/>
+                </a:solidFill>
+                <a:latin typeface="Arial" pitchFamily="34" charset="0"/>
+                <a:ea typeface="Arial" pitchFamily="34" charset="-122"/>
+                <a:cs typeface="Arial" pitchFamily="34" charset="-120"/>
+              </a:rPr>
+              <a:t>Hell and death will not defeat us</a:t>
+            </a:r>
+            <a:endParaRPr lang="en-US" sz="4800" dirty="0"/>
+          </a:p>
+          <a:p>
+            <a:pPr algn="ctr" indent="0" marL="0">
+              <a:buNone/>
+            </a:pPr>
+            <a:r>
+              <a:rPr lang="en-US" sz="4800" b="1" dirty="0">
+                <a:solidFill>
+                  <a:srgbClr val="FFFFFF"/>
+                </a:solidFill>
+                <a:latin typeface="Arial" pitchFamily="34" charset="0"/>
+                <a:ea typeface="Arial" pitchFamily="34" charset="-122"/>
+                <a:cs typeface="Arial" pitchFamily="34" charset="-120"/>
+              </a:rPr>
+              <a:t>He who gave His son to free us,</a:t>
+            </a:r>
+            <a:endParaRPr lang="en-US" sz="4800" dirty="0"/>
+          </a:p>
+          <a:p>
+            <a:pPr algn="ctr" indent="0" marL="0">
+              <a:buNone/>
+            </a:pPr>
+            <a:r>
+              <a:rPr lang="en-US" sz="4800" b="1" dirty="0">
+                <a:solidFill>
+                  <a:srgbClr val="FFFFFF"/>
+                </a:solidFill>
+                <a:latin typeface="Arial" pitchFamily="34" charset="0"/>
+                <a:ea typeface="Arial" pitchFamily="34" charset="-122"/>
+                <a:cs typeface="Arial" pitchFamily="34" charset="-120"/>
+              </a:rPr>
+              <a:t>Holds me in His love</a:t>
+            </a:r>
+            <a:endParaRPr lang="en-US" sz="4800" dirty="0"/>
+          </a:p>
+        </p:txBody>
+      </p:sp>
+    </p:spTree>
+  </p:cSld>
+  <p:clrMapOvr>
+    <a:masterClrMapping/>
+  </p:clrMapOvr>
+</p:sld>
+</file>
+
+<file path=ppt/slides/slide12.xml><?xml version="1.0" encoding="utf-8"?>
+<p:sld xmlns:a="http://schemas.openxmlformats.org/drawingml/2006/main" xmlns:r="http://schemas.openxmlformats.org/officeDocument/2006/relationships" xmlns:p="http://schemas.openxmlformats.org/presentationml/2006/main">
+  <p:cSld name="Slide 12">
+    <p:bg>
+      <p:bgPr>
+        <a:solidFill>
+          <a:srgbClr val="000000"/>
+        </a:solidFill>
+      </p:bgPr>
+    </p:bg>
+    <p:spTree>
+      <p:nvGrpSpPr>
+        <p:cNvPr id="1" name=""/>
+        <p:cNvGrpSpPr/>
+        <p:nvPr/>
+      </p:nvGrpSpPr>
+      <p:grpSpPr>
+        <a:xfrm>
+          <a:off x="0" y="0"/>
+          <a:ext cx="0" cy="0"/>
+          <a:chOff x="0" y="0"/>
+          <a:chExt cx="0" cy="0"/>
+        </a:xfrm>
+      </p:grpSpPr>
+      <p:sp>
+        <p:nvSpPr>
+          <p:cNvPr id="2" name="Text 0"/>
+          <p:cNvSpPr txBox="1"/>
+          <p:nvPr/>
+        </p:nvSpPr>
+        <p:spPr>
+          <a:xfrm>
+            <a:off x="548640" y="457200"/>
+            <a:ext cx="11064240" cy="5943600"/>
+          </a:xfrm>
+          <a:prstGeom prst="rect">
+            <a:avLst/>
+          </a:prstGeom>
+          <a:noFill/>
+          <a:ln/>
+        </p:spPr>
+        <p:txBody>
+          <a:bodyPr wrap="square" lIns="0" tIns="0" rIns="0" bIns="0" rtlCol="0" anchor="ctr"/>
+          <a:lstStyle/>
+          <a:p>
+            <a:pPr algn="ctr" indent="0" marL="0">
+              <a:buNone/>
+            </a:pPr>
+            <a:r>
+              <a:rPr lang="en-US" sz="4800" b="1" i="1" dirty="0">
+                <a:solidFill>
+                  <a:srgbClr val="FFFFFF"/>
+                </a:solidFill>
+                <a:latin typeface="Arial" pitchFamily="34" charset="0"/>
+                <a:ea typeface="Arial" pitchFamily="34" charset="-122"/>
+                <a:cs typeface="Arial" pitchFamily="34" charset="-120"/>
+              </a:rPr>
+              <a:t>Sing with joy now: </a:t>
+            </a:r>
+            <a:endParaRPr lang="en-US" sz="4800" dirty="0"/>
+          </a:p>
+          <a:p>
+            <a:pPr algn="ctr" indent="0" marL="0">
+              <a:buNone/>
+            </a:pPr>
+            <a:r>
+              <a:rPr lang="en-US" sz="4800" b="1" i="1" dirty="0">
+                <a:solidFill>
+                  <a:srgbClr val="FFFFFF"/>
+                </a:solidFill>
+                <a:latin typeface="Arial" pitchFamily="34" charset="0"/>
+                <a:ea typeface="Arial" pitchFamily="34" charset="-122"/>
+                <a:cs typeface="Arial" pitchFamily="34" charset="-120"/>
+              </a:rPr>
+              <a:t>our God is for us.</a:t>
+            </a:r>
+            <a:endParaRPr lang="en-US" sz="4800" dirty="0"/>
+          </a:p>
+          <a:p>
+            <a:pPr algn="ctr" indent="0" marL="0">
+              <a:buNone/>
+            </a:pPr>
+            <a:r>
+              <a:rPr lang="en-US" sz="4800" b="1" i="1" dirty="0">
+                <a:solidFill>
+                  <a:srgbClr val="FFFFFF"/>
+                </a:solidFill>
+                <a:latin typeface="Arial" pitchFamily="34" charset="0"/>
+                <a:ea typeface="Arial" pitchFamily="34" charset="-122"/>
+                <a:cs typeface="Arial" pitchFamily="34" charset="-120"/>
+              </a:rPr>
+              <a:t>The Father's love is </a:t>
+            </a:r>
+            <a:endParaRPr lang="en-US" sz="4800" dirty="0"/>
+          </a:p>
+          <a:p>
+            <a:pPr algn="ctr" indent="0" marL="0">
+              <a:buNone/>
+            </a:pPr>
+            <a:r>
+              <a:rPr lang="en-US" sz="4800" b="1" i="1" dirty="0">
+                <a:solidFill>
+                  <a:srgbClr val="FFFFFF"/>
+                </a:solidFill>
+                <a:latin typeface="Arial" pitchFamily="34" charset="0"/>
+                <a:ea typeface="Arial" pitchFamily="34" charset="-122"/>
+                <a:cs typeface="Arial" pitchFamily="34" charset="-120"/>
+              </a:rPr>
+              <a:t>a strong and mighty fortress</a:t>
+            </a:r>
+            <a:endParaRPr lang="en-US" sz="4800" dirty="0"/>
+          </a:p>
+        </p:txBody>
+      </p:sp>
+    </p:spTree>
+  </p:cSld>
+  <p:clrMapOvr>
+    <a:masterClrMapping/>
+  </p:clrMapOvr>
+</p:sld>
+</file>
+
+<file path=ppt/slides/slide13.xml><?xml version="1.0" encoding="utf-8"?>
+<p:sld xmlns:a="http://schemas.openxmlformats.org/drawingml/2006/main" xmlns:r="http://schemas.openxmlformats.org/officeDocument/2006/relationships" xmlns:p="http://schemas.openxmlformats.org/presentationml/2006/main">
+  <p:cSld name="Slide 13">
+    <p:bg>
+      <p:bgPr>
+        <a:solidFill>
+          <a:srgbClr val="000000"/>
+        </a:solidFill>
+      </p:bgPr>
+    </p:bg>
+    <p:spTree>
+      <p:nvGrpSpPr>
+        <p:cNvPr id="1" name=""/>
+        <p:cNvGrpSpPr/>
+        <p:nvPr/>
+      </p:nvGrpSpPr>
+      <p:grpSpPr>
+        <a:xfrm>
+          <a:off x="0" y="0"/>
+          <a:ext cx="0" cy="0"/>
+          <a:chOff x="0" y="0"/>
+          <a:chExt cx="0" cy="0"/>
+        </a:xfrm>
+      </p:grpSpPr>
+      <p:sp>
+        <p:nvSpPr>
+          <p:cNvPr id="2" name="Text 0"/>
+          <p:cNvSpPr txBox="1"/>
+          <p:nvPr/>
+        </p:nvSpPr>
+        <p:spPr>
+          <a:xfrm>
+            <a:off x="548640" y="457200"/>
+            <a:ext cx="11064240" cy="5943600"/>
+          </a:xfrm>
+          <a:prstGeom prst="rect">
+            <a:avLst/>
+          </a:prstGeom>
+          <a:noFill/>
+          <a:ln/>
+        </p:spPr>
+        <p:txBody>
+          <a:bodyPr wrap="square" lIns="0" tIns="0" rIns="0" bIns="0" rtlCol="0" anchor="ctr"/>
+          <a:lstStyle/>
+          <a:p>
+            <a:pPr algn="ctr" indent="0" marL="0">
+              <a:buNone/>
+            </a:pPr>
+            <a:r>
+              <a:rPr lang="en-US" sz="4800" b="1" i="1" dirty="0">
+                <a:solidFill>
+                  <a:srgbClr val="FFFFFF"/>
+                </a:solidFill>
+                <a:latin typeface="Arial" pitchFamily="34" charset="0"/>
+                <a:ea typeface="Arial" pitchFamily="34" charset="-122"/>
+                <a:cs typeface="Arial" pitchFamily="34" charset="-120"/>
+              </a:rPr>
+              <a:t>Raise your voice now, </a:t>
+            </a:r>
+            <a:endParaRPr lang="en-US" sz="4800" dirty="0"/>
+          </a:p>
+          <a:p>
+            <a:pPr algn="ctr" indent="0" marL="0">
+              <a:buNone/>
+            </a:pPr>
+            <a:r>
+              <a:rPr lang="en-US" sz="4800" b="1" i="1" dirty="0">
+                <a:solidFill>
+                  <a:srgbClr val="FFFFFF"/>
+                </a:solidFill>
+                <a:latin typeface="Arial" pitchFamily="34" charset="0"/>
+                <a:ea typeface="Arial" pitchFamily="34" charset="-122"/>
+                <a:cs typeface="Arial" pitchFamily="34" charset="-120"/>
+              </a:rPr>
+              <a:t>no love is greater.</a:t>
+            </a:r>
+            <a:endParaRPr lang="en-US" sz="4800" dirty="0"/>
+          </a:p>
+          <a:p>
+            <a:pPr algn="ctr" indent="0" marL="0">
+              <a:buNone/>
+            </a:pPr>
+            <a:r>
+              <a:rPr lang="en-US" sz="4800" b="1" i="1" dirty="0">
+                <a:solidFill>
+                  <a:srgbClr val="FFFFFF"/>
+                </a:solidFill>
+                <a:latin typeface="Arial" pitchFamily="34" charset="0"/>
+                <a:ea typeface="Arial" pitchFamily="34" charset="-122"/>
+                <a:cs typeface="Arial" pitchFamily="34" charset="-120"/>
+              </a:rPr>
+              <a:t>Who can stand against us </a:t>
+            </a:r>
+            <a:endParaRPr lang="en-US" sz="4800" dirty="0"/>
+          </a:p>
+          <a:p>
+            <a:pPr algn="ctr" indent="0" marL="0">
+              <a:buNone/>
+            </a:pPr>
+            <a:r>
+              <a:rPr lang="en-US" sz="4800" b="1" i="1" dirty="0">
+                <a:solidFill>
+                  <a:srgbClr val="FFFFFF"/>
+                </a:solidFill>
+                <a:latin typeface="Arial" pitchFamily="34" charset="0"/>
+                <a:ea typeface="Arial" pitchFamily="34" charset="-122"/>
+                <a:cs typeface="Arial" pitchFamily="34" charset="-120"/>
+              </a:rPr>
+              <a:t>if our God is for us</a:t>
+            </a:r>
+            <a:endParaRPr lang="en-US" sz="4800" dirty="0"/>
+          </a:p>
+          <a:p>
+            <a:pPr algn="ctr" indent="0" marL="0">
+              <a:buNone/>
+            </a:pPr>
+            <a:endParaRPr lang="en-US" sz="4800" dirty="0"/>
+          </a:p>
+          <a:p>
+            <a:pPr algn="ctr" indent="0" marL="0">
+              <a:buNone/>
+            </a:pPr>
+            <a:r>
+              <a:rPr lang="en-US" sz="4800" b="1" i="1" dirty="0">
+                <a:solidFill>
+                  <a:srgbClr val="FFFFFF"/>
+                </a:solidFill>
+                <a:latin typeface="Arial" pitchFamily="34" charset="0"/>
+                <a:ea typeface="Arial" pitchFamily="34" charset="-122"/>
+                <a:cs typeface="Arial" pitchFamily="34" charset="-120"/>
+              </a:rPr>
+              <a:t>***</a:t>
+            </a:r>
+            <a:endParaRPr lang="en-US" sz="4800" dirty="0"/>
+          </a:p>
+        </p:txBody>
+      </p:sp>
+    </p:spTree>
+  </p:cSld>
+  <p:clrMapOvr>
+    <a:masterClrMapping/>
+  </p:clrMapOvr>
+</p:sld>
+</file>
+
 <file path=ppt/slides/slide2.xml><?xml version="1.0" encoding="utf-8"?>
 <p:sld xmlns:a="http://schemas.openxmlformats.org/drawingml/2006/main" xmlns:r="http://schemas.openxmlformats.org/officeDocument/2006/relationships" xmlns:p="http://schemas.openxmlformats.org/presentationml/2006/main">
   <p:cSld name="Slide 2">
@@ -1602,7 +2558,7 @@
                 <a:ea typeface="Arial" pitchFamily="34" charset="-122"/>
                 <a:cs typeface="Arial" pitchFamily="34" charset="-120"/>
               </a:rPr>
-              <a:t>We won't fear the battle, we won’t fear the night</a:t>
+              <a:t>We won't fear the battle, </a:t>
             </a:r>
             <a:endParaRPr lang="en-US" sz="4800" dirty="0"/>
           </a:p>
@@ -1619,7 +2575,7 @@
                 <a:ea typeface="Arial" pitchFamily="34" charset="-122"/>
                 <a:cs typeface="Arial" pitchFamily="34" charset="-120"/>
               </a:rPr>
-              <a:t>We will walk the valley with You by our side</a:t>
+              <a:t>we won’t fear the night</a:t>
             </a:r>
             <a:endParaRPr lang="en-US" sz="4800" dirty="0"/>
           </a:p>
@@ -1636,7 +2592,7 @@
                 <a:ea typeface="Arial" pitchFamily="34" charset="-122"/>
                 <a:cs typeface="Arial" pitchFamily="34" charset="-120"/>
               </a:rPr>
-              <a:t>You will go before us, You will lead the way</a:t>
+              <a:t>We will walk the valley </a:t>
             </a:r>
             <a:endParaRPr lang="en-US" sz="4800" dirty="0"/>
           </a:p>
@@ -1653,7 +2609,7 @@
                 <a:ea typeface="Arial" pitchFamily="34" charset="-122"/>
                 <a:cs typeface="Arial" pitchFamily="34" charset="-120"/>
               </a:rPr>
-              <a:t>We have found a refuge, only You can save</a:t>
+              <a:t>with You by our side</a:t>
             </a:r>
             <a:endParaRPr lang="en-US" sz="4800" dirty="0"/>
           </a:p>
@@ -1716,66 +2672,66 @@
               <a:buNone/>
             </a:pPr>
             <a:r>
-              <a:rPr lang="en-US" sz="4800" b="1" i="1" dirty="0">
-                <a:solidFill>
-                  <a:srgbClr val="FFFFFF"/>
-                </a:solidFill>
-                <a:latin typeface="Arial" pitchFamily="34" charset="0"/>
-                <a:ea typeface="Arial" pitchFamily="34" charset="-122"/>
-                <a:cs typeface="Arial" pitchFamily="34" charset="-120"/>
-              </a:rPr>
-              <a:t>Sing with joy now: our God is for us.</a:t>
-            </a:r>
-            <a:endParaRPr lang="en-US" sz="4800" dirty="0"/>
-          </a:p>
-          <a:p>
-            <a:pPr algn="ctr" indent="0" marL="0">
-              <a:buNone/>
-            </a:pPr>
-            <a:r>
-              <a:rPr lang="en-US" sz="4800" b="1" i="1" dirty="0">
-                <a:solidFill>
-                  <a:srgbClr val="FFFFFF"/>
-                </a:solidFill>
-                <a:latin typeface="Arial" pitchFamily="34" charset="0"/>
-                <a:ea typeface="Arial" pitchFamily="34" charset="-122"/>
-                <a:cs typeface="Arial" pitchFamily="34" charset="-120"/>
-              </a:rPr>
-              <a:t>The Father's love is a strong and mighty fortress</a:t>
-            </a:r>
-            <a:endParaRPr lang="en-US" sz="4800" dirty="0"/>
-          </a:p>
-          <a:p>
-            <a:pPr algn="ctr" indent="0" marL="0">
-              <a:buNone/>
-            </a:pPr>
-            <a:r>
-              <a:rPr lang="en-US" sz="4800" b="1" i="1" dirty="0">
-                <a:solidFill>
-                  <a:srgbClr val="FFFFFF"/>
-                </a:solidFill>
-                <a:latin typeface="Arial" pitchFamily="34" charset="0"/>
-                <a:ea typeface="Arial" pitchFamily="34" charset="-122"/>
-                <a:cs typeface="Arial" pitchFamily="34" charset="-120"/>
-              </a:rPr>
-              <a:t>Raise your voice now, no love is greater.</a:t>
-            </a:r>
-            <a:endParaRPr lang="en-US" sz="4800" dirty="0"/>
-          </a:p>
-          <a:p>
-            <a:pPr algn="ctr" indent="0" marL="0">
-              <a:buNone/>
-            </a:pPr>
-            <a:r>
-              <a:rPr lang="en-US" sz="4800" b="1" i="1" dirty="0">
-                <a:solidFill>
-                  <a:srgbClr val="FFFFFF"/>
-                </a:solidFill>
-                <a:latin typeface="Arial" pitchFamily="34" charset="0"/>
-                <a:ea typeface="Arial" pitchFamily="34" charset="-122"/>
-                <a:cs typeface="Arial" pitchFamily="34" charset="-120"/>
-              </a:rPr>
-              <a:t>Who can stand against us if our God is for us</a:t>
+              <a:rPr lang="en-US" sz="4800" b="1" dirty="0">
+                <a:solidFill>
+                  <a:srgbClr val="FFFFFF"/>
+                </a:solidFill>
+                <a:latin typeface="Arial" pitchFamily="34" charset="0"/>
+                <a:ea typeface="Arial" pitchFamily="34" charset="-122"/>
+                <a:cs typeface="Arial" pitchFamily="34" charset="-120"/>
+              </a:rPr>
+              <a:t>You will go before us, </a:t>
+            </a:r>
+            <a:endParaRPr lang="en-US" sz="4800" dirty="0"/>
+          </a:p>
+          <a:p>
+            <a:pPr algn="ctr" indent="0" marL="0">
+              <a:buNone/>
+            </a:pPr>
+            <a:r>
+              <a:rPr lang="en-US" sz="4800" b="1" dirty="0">
+                <a:solidFill>
+                  <a:srgbClr val="FFFFFF"/>
+                </a:solidFill>
+                <a:latin typeface="Arial" pitchFamily="34" charset="0"/>
+                <a:ea typeface="Arial" pitchFamily="34" charset="-122"/>
+                <a:cs typeface="Arial" pitchFamily="34" charset="-120"/>
+              </a:rPr>
+              <a:t>You will lead the way</a:t>
+            </a:r>
+            <a:endParaRPr lang="en-US" sz="4800" dirty="0"/>
+          </a:p>
+          <a:p>
+            <a:pPr algn="ctr" indent="0" marL="0">
+              <a:buNone/>
+            </a:pPr>
+            <a:r>
+              <a:rPr lang="en-US" sz="4800" b="1" dirty="0">
+                <a:solidFill>
+                  <a:srgbClr val="FFFFFF"/>
+                </a:solidFill>
+                <a:latin typeface="Arial" pitchFamily="34" charset="0"/>
+                <a:ea typeface="Arial" pitchFamily="34" charset="-122"/>
+                <a:cs typeface="Arial" pitchFamily="34" charset="-120"/>
+              </a:rPr>
+              <a:t>We have found a refuge, </a:t>
+            </a:r>
+            <a:endParaRPr lang="en-US" sz="4800" dirty="0"/>
+          </a:p>
+          <a:p>
+            <a:pPr algn="ctr" indent="0" marL="0">
+              <a:buNone/>
+            </a:pPr>
+            <a:r>
+              <a:rPr lang="en-US" sz="4800" b="1" dirty="0">
+                <a:solidFill>
+                  <a:srgbClr val="FFFFFF"/>
+                </a:solidFill>
+                <a:latin typeface="Arial" pitchFamily="34" charset="0"/>
+                <a:ea typeface="Arial" pitchFamily="34" charset="-122"/>
+                <a:cs typeface="Arial" pitchFamily="34" charset="-120"/>
+              </a:rPr>
+              <a:t>only You can save</a:t>
             </a:r>
             <a:endParaRPr lang="en-US" sz="4800" dirty="0"/>
           </a:p>
@@ -1838,66 +2794,66 @@
               <a:buNone/>
             </a:pPr>
             <a:r>
-              <a:rPr lang="en-US" sz="4800" b="1" dirty="0">
-                <a:solidFill>
-                  <a:srgbClr val="FFFFFF"/>
-                </a:solidFill>
-                <a:latin typeface="Arial" pitchFamily="34" charset="0"/>
-                <a:ea typeface="Arial" pitchFamily="34" charset="-122"/>
-                <a:cs typeface="Arial" pitchFamily="34" charset="-120"/>
-              </a:rPr>
-              <a:t>Even when I stumble, even when I fall</a:t>
-            </a:r>
-            <a:endParaRPr lang="en-US" sz="4800" dirty="0"/>
-          </a:p>
-          <a:p>
-            <a:pPr algn="ctr" indent="0" marL="0">
-              <a:buNone/>
-            </a:pPr>
-            <a:r>
-              <a:rPr lang="en-US" sz="4800" b="1" dirty="0">
-                <a:solidFill>
-                  <a:srgbClr val="FFFFFF"/>
-                </a:solidFill>
-                <a:latin typeface="Arial" pitchFamily="34" charset="0"/>
-                <a:ea typeface="Arial" pitchFamily="34" charset="-122"/>
-                <a:cs typeface="Arial" pitchFamily="34" charset="-120"/>
-              </a:rPr>
-              <a:t>Even when I turn back, still Your love is sure</a:t>
-            </a:r>
-            <a:endParaRPr lang="en-US" sz="4800" dirty="0"/>
-          </a:p>
-          <a:p>
-            <a:pPr algn="ctr" indent="0" marL="0">
-              <a:buNone/>
-            </a:pPr>
-            <a:r>
-              <a:rPr lang="en-US" sz="4800" b="1" dirty="0">
-                <a:solidFill>
-                  <a:srgbClr val="FFFFFF"/>
-                </a:solidFill>
-                <a:latin typeface="Arial" pitchFamily="34" charset="0"/>
-                <a:ea typeface="Arial" pitchFamily="34" charset="-122"/>
-                <a:cs typeface="Arial" pitchFamily="34" charset="-120"/>
-              </a:rPr>
-              <a:t>You will not abandon, You will not forsake</a:t>
-            </a:r>
-            <a:endParaRPr lang="en-US" sz="4800" dirty="0"/>
-          </a:p>
-          <a:p>
-            <a:pPr algn="ctr" indent="0" marL="0">
-              <a:buNone/>
-            </a:pPr>
-            <a:r>
-              <a:rPr lang="en-US" sz="4800" b="1" dirty="0">
-                <a:solidFill>
-                  <a:srgbClr val="FFFFFF"/>
-                </a:solidFill>
-                <a:latin typeface="Arial" pitchFamily="34" charset="0"/>
-                <a:ea typeface="Arial" pitchFamily="34" charset="-122"/>
-                <a:cs typeface="Arial" pitchFamily="34" charset="-120"/>
-              </a:rPr>
-              <a:t>You will carry me with never-ending grace</a:t>
+              <a:rPr lang="en-US" sz="4800" b="1" i="1" dirty="0">
+                <a:solidFill>
+                  <a:srgbClr val="FFFFFF"/>
+                </a:solidFill>
+                <a:latin typeface="Arial" pitchFamily="34" charset="0"/>
+                <a:ea typeface="Arial" pitchFamily="34" charset="-122"/>
+                <a:cs typeface="Arial" pitchFamily="34" charset="-120"/>
+              </a:rPr>
+              <a:t>Sing with joy now: </a:t>
+            </a:r>
+            <a:endParaRPr lang="en-US" sz="4800" dirty="0"/>
+          </a:p>
+          <a:p>
+            <a:pPr algn="ctr" indent="0" marL="0">
+              <a:buNone/>
+            </a:pPr>
+            <a:r>
+              <a:rPr lang="en-US" sz="4800" b="1" i="1" dirty="0">
+                <a:solidFill>
+                  <a:srgbClr val="FFFFFF"/>
+                </a:solidFill>
+                <a:latin typeface="Arial" pitchFamily="34" charset="0"/>
+                <a:ea typeface="Arial" pitchFamily="34" charset="-122"/>
+                <a:cs typeface="Arial" pitchFamily="34" charset="-120"/>
+              </a:rPr>
+              <a:t>our God is for us.</a:t>
+            </a:r>
+            <a:endParaRPr lang="en-US" sz="4800" dirty="0"/>
+          </a:p>
+          <a:p>
+            <a:pPr algn="ctr" indent="0" marL="0">
+              <a:buNone/>
+            </a:pPr>
+            <a:r>
+              <a:rPr lang="en-US" sz="4800" b="1" i="1" dirty="0">
+                <a:solidFill>
+                  <a:srgbClr val="FFFFFF"/>
+                </a:solidFill>
+                <a:latin typeface="Arial" pitchFamily="34" charset="0"/>
+                <a:ea typeface="Arial" pitchFamily="34" charset="-122"/>
+                <a:cs typeface="Arial" pitchFamily="34" charset="-120"/>
+              </a:rPr>
+              <a:t>The Father's love is </a:t>
+            </a:r>
+            <a:endParaRPr lang="en-US" sz="4800" dirty="0"/>
+          </a:p>
+          <a:p>
+            <a:pPr algn="ctr" indent="0" marL="0">
+              <a:buNone/>
+            </a:pPr>
+            <a:r>
+              <a:rPr lang="en-US" sz="4800" b="1" i="1" dirty="0">
+                <a:solidFill>
+                  <a:srgbClr val="FFFFFF"/>
+                </a:solidFill>
+                <a:latin typeface="Arial" pitchFamily="34" charset="0"/>
+                <a:ea typeface="Arial" pitchFamily="34" charset="-122"/>
+                <a:cs typeface="Arial" pitchFamily="34" charset="-120"/>
+              </a:rPr>
+              <a:t>a strong and mighty fortress</a:t>
             </a:r>
             <a:endParaRPr lang="en-US" sz="4800" dirty="0"/>
           </a:p>
@@ -1968,7 +2924,7 @@
                 <a:ea typeface="Arial" pitchFamily="34" charset="-122"/>
                 <a:cs typeface="Arial" pitchFamily="34" charset="-120"/>
               </a:rPr>
-              <a:t>Sing with joy now: our God is for us.</a:t>
+              <a:t>Raise your voice now, </a:t>
             </a:r>
             <a:endParaRPr lang="en-US" sz="4800" dirty="0"/>
           </a:p>
@@ -1985,7 +2941,7 @@
                 <a:ea typeface="Arial" pitchFamily="34" charset="-122"/>
                 <a:cs typeface="Arial" pitchFamily="34" charset="-120"/>
               </a:rPr>
-              <a:t>The Father's love is a strong and mighty fortress</a:t>
+              <a:t>no love is greater.</a:t>
             </a:r>
             <a:endParaRPr lang="en-US" sz="4800" dirty="0"/>
           </a:p>
@@ -2002,7 +2958,7 @@
                 <a:ea typeface="Arial" pitchFamily="34" charset="-122"/>
                 <a:cs typeface="Arial" pitchFamily="34" charset="-120"/>
               </a:rPr>
-              <a:t>Raise your voice now, no love is greater.</a:t>
+              <a:t>Who can stand against us </a:t>
             </a:r>
             <a:endParaRPr lang="en-US" sz="4800" dirty="0"/>
           </a:p>
@@ -2019,7 +2975,7 @@
                 <a:ea typeface="Arial" pitchFamily="34" charset="-122"/>
                 <a:cs typeface="Arial" pitchFamily="34" charset="-120"/>
               </a:rPr>
-              <a:t>Who can stand against us if our God is for us</a:t>
+              <a:t>if our God is for us</a:t>
             </a:r>
             <a:endParaRPr lang="en-US" sz="4800" dirty="0"/>
           </a:p>
@@ -2090,7 +3046,7 @@
                 <a:ea typeface="Arial" pitchFamily="34" charset="-122"/>
                 <a:cs typeface="Arial" pitchFamily="34" charset="-120"/>
               </a:rPr>
-              <a:t>Neither height nor depth can separate us,</a:t>
+              <a:t>Even when I stumble, </a:t>
             </a:r>
             <a:endParaRPr lang="en-US" sz="4800" dirty="0"/>
           </a:p>
@@ -2107,7 +3063,7 @@
                 <a:ea typeface="Arial" pitchFamily="34" charset="-122"/>
                 <a:cs typeface="Arial" pitchFamily="34" charset="-120"/>
               </a:rPr>
-              <a:t>Hell and death will not defeat us</a:t>
+              <a:t>even when I fall</a:t>
             </a:r>
             <a:endParaRPr lang="en-US" sz="4800" dirty="0"/>
           </a:p>
@@ -2124,7 +3080,7 @@
                 <a:ea typeface="Arial" pitchFamily="34" charset="-122"/>
                 <a:cs typeface="Arial" pitchFamily="34" charset="-120"/>
               </a:rPr>
-              <a:t>He who gave His son to free us,</a:t>
+              <a:t>Even when I turn back, </a:t>
             </a:r>
             <a:endParaRPr lang="en-US" sz="4800" dirty="0"/>
           </a:p>
@@ -2141,7 +3097,7 @@
                 <a:ea typeface="Arial" pitchFamily="34" charset="-122"/>
                 <a:cs typeface="Arial" pitchFamily="34" charset="-120"/>
               </a:rPr>
-              <a:t>Holds me in His love</a:t>
+              <a:t>still Your love is sure</a:t>
             </a:r>
             <a:endParaRPr lang="en-US" sz="4800" dirty="0"/>
           </a:p>
@@ -2212,7 +3168,7 @@
                 <a:ea typeface="Arial" pitchFamily="34" charset="-122"/>
                 <a:cs typeface="Arial" pitchFamily="34" charset="-120"/>
               </a:rPr>
-              <a:t>Neither height nor depth can separate us,</a:t>
+              <a:t>You will not abandon,</a:t>
             </a:r>
             <a:endParaRPr lang="en-US" sz="4800" dirty="0"/>
           </a:p>
@@ -2229,7 +3185,7 @@
                 <a:ea typeface="Arial" pitchFamily="34" charset="-122"/>
                 <a:cs typeface="Arial" pitchFamily="34" charset="-120"/>
               </a:rPr>
-              <a:t>Hell and death will not defeat us</a:t>
+              <a:t>You will not forsake</a:t>
             </a:r>
             <a:endParaRPr lang="en-US" sz="4800" dirty="0"/>
           </a:p>
@@ -2246,7 +3202,7 @@
                 <a:ea typeface="Arial" pitchFamily="34" charset="-122"/>
                 <a:cs typeface="Arial" pitchFamily="34" charset="-120"/>
               </a:rPr>
-              <a:t>He who gave His son to free us,</a:t>
+              <a:t>You will carry me with </a:t>
             </a:r>
             <a:endParaRPr lang="en-US" sz="4800" dirty="0"/>
           </a:p>
@@ -2263,7 +3219,7 @@
                 <a:ea typeface="Arial" pitchFamily="34" charset="-122"/>
                 <a:cs typeface="Arial" pitchFamily="34" charset="-120"/>
               </a:rPr>
-              <a:t>Holds me in His love</a:t>
+              <a:t>never-ending grace</a:t>
             </a:r>
             <a:endParaRPr lang="en-US" sz="4800" dirty="0"/>
           </a:p>
@@ -2334,7 +3290,7 @@
                 <a:ea typeface="Arial" pitchFamily="34" charset="-122"/>
                 <a:cs typeface="Arial" pitchFamily="34" charset="-120"/>
               </a:rPr>
-              <a:t>Sing with joy now: our God is for us.</a:t>
+              <a:t>Sing with joy now: </a:t>
             </a:r>
             <a:endParaRPr lang="en-US" sz="4800" dirty="0"/>
           </a:p>
@@ -2351,7 +3307,7 @@
                 <a:ea typeface="Arial" pitchFamily="34" charset="-122"/>
                 <a:cs typeface="Arial" pitchFamily="34" charset="-120"/>
               </a:rPr>
-              <a:t>The Father's love is a strong and mighty fortress</a:t>
+              <a:t>our God is for us.</a:t>
             </a:r>
             <a:endParaRPr lang="en-US" sz="4800" dirty="0"/>
           </a:p>
@@ -2368,7 +3324,7 @@
                 <a:ea typeface="Arial" pitchFamily="34" charset="-122"/>
                 <a:cs typeface="Arial" pitchFamily="34" charset="-120"/>
               </a:rPr>
-              <a:t>Raise your voice now, no love is greater.</a:t>
+              <a:t>The Father's love is </a:t>
             </a:r>
             <a:endParaRPr lang="en-US" sz="4800" dirty="0"/>
           </a:p>
@@ -2385,10 +3341,64 @@
                 <a:ea typeface="Arial" pitchFamily="34" charset="-122"/>
                 <a:cs typeface="Arial" pitchFamily="34" charset="-120"/>
               </a:rPr>
-              <a:t>Who can stand against us if our God is for us</a:t>
-            </a:r>
-            <a:endParaRPr lang="en-US" sz="4800" dirty="0"/>
-          </a:p>
+              <a:t>a strong and mighty fortress</a:t>
+            </a:r>
+            <a:endParaRPr lang="en-US" sz="4800" dirty="0"/>
+          </a:p>
+        </p:txBody>
+      </p:sp>
+    </p:spTree>
+  </p:cSld>
+  <p:clrMapOvr>
+    <a:masterClrMapping/>
+  </p:clrMapOvr>
+</p:sld>
+</file>
+
+<file path=ppt/slides/slide9.xml><?xml version="1.0" encoding="utf-8"?>
+<p:sld xmlns:a="http://schemas.openxmlformats.org/drawingml/2006/main" xmlns:r="http://schemas.openxmlformats.org/officeDocument/2006/relationships" xmlns:p="http://schemas.openxmlformats.org/presentationml/2006/main">
+  <p:cSld name="Slide 9">
+    <p:bg>
+      <p:bgPr>
+        <a:solidFill>
+          <a:srgbClr val="000000"/>
+        </a:solidFill>
+      </p:bgPr>
+    </p:bg>
+    <p:spTree>
+      <p:nvGrpSpPr>
+        <p:cNvPr id="1" name=""/>
+        <p:cNvGrpSpPr/>
+        <p:nvPr/>
+      </p:nvGrpSpPr>
+      <p:grpSpPr>
+        <a:xfrm>
+          <a:off x="0" y="0"/>
+          <a:ext cx="0" cy="0"/>
+          <a:chOff x="0" y="0"/>
+          <a:chExt cx="0" cy="0"/>
+        </a:xfrm>
+      </p:grpSpPr>
+      <p:sp>
+        <p:nvSpPr>
+          <p:cNvPr id="2" name="Text 0"/>
+          <p:cNvSpPr txBox="1"/>
+          <p:nvPr/>
+        </p:nvSpPr>
+        <p:spPr>
+          <a:xfrm>
+            <a:off x="548640" y="457200"/>
+            <a:ext cx="11064240" cy="5943600"/>
+          </a:xfrm>
+          <a:prstGeom prst="rect">
+            <a:avLst/>
+          </a:prstGeom>
+          <a:noFill/>
+          <a:ln/>
+        </p:spPr>
+        <p:txBody>
+          <a:bodyPr wrap="square" lIns="0" tIns="0" rIns="0" bIns="0" rtlCol="0" anchor="ctr"/>
+          <a:lstStyle/>
           <a:p>
             <a:pPr algn="ctr" indent="0" marL="0">
               <a:buNone/>
@@ -2402,7 +3412,58 @@
                 <a:ea typeface="Arial" pitchFamily="34" charset="-122"/>
                 <a:cs typeface="Arial" pitchFamily="34" charset="-120"/>
               </a:rPr>
-              <a:t>***</a:t>
+              <a:t>Raise your voice now, </a:t>
+            </a:r>
+            <a:endParaRPr lang="en-US" sz="4800" dirty="0"/>
+          </a:p>
+          <a:p>
+            <a:pPr algn="ctr" indent="0" marL="0">
+              <a:buNone/>
+            </a:pPr>
+            <a:r>
+              <a:rPr lang="en-US" sz="4800" b="1" i="1" dirty="0">
+                <a:solidFill>
+                  <a:srgbClr val="FFFFFF"/>
+                </a:solidFill>
+                <a:latin typeface="Arial" pitchFamily="34" charset="0"/>
+                <a:ea typeface="Arial" pitchFamily="34" charset="-122"/>
+                <a:cs typeface="Arial" pitchFamily="34" charset="-120"/>
+              </a:rPr>
+              <a:t>no love is greater.</a:t>
+            </a:r>
+            <a:endParaRPr lang="en-US" sz="4800" dirty="0"/>
+          </a:p>
+          <a:p>
+            <a:pPr algn="ctr" indent="0" marL="0">
+              <a:buNone/>
+            </a:pPr>
+            <a:r>
+              <a:rPr lang="en-US" sz="4800" b="1" i="1" dirty="0">
+                <a:solidFill>
+                  <a:srgbClr val="FFFFFF"/>
+                </a:solidFill>
+                <a:latin typeface="Arial" pitchFamily="34" charset="0"/>
+                <a:ea typeface="Arial" pitchFamily="34" charset="-122"/>
+                <a:cs typeface="Arial" pitchFamily="34" charset="-120"/>
+              </a:rPr>
+              <a:t>Who can stand against us </a:t>
+            </a:r>
+            <a:endParaRPr lang="en-US" sz="4800" dirty="0"/>
+          </a:p>
+          <a:p>
+            <a:pPr algn="ctr" indent="0" marL="0">
+              <a:buNone/>
+            </a:pPr>
+            <a:r>
+              <a:rPr lang="en-US" sz="4800" b="1" i="1" dirty="0">
+                <a:solidFill>
+                  <a:srgbClr val="FFFFFF"/>
+                </a:solidFill>
+                <a:latin typeface="Arial" pitchFamily="34" charset="0"/>
+                <a:ea typeface="Arial" pitchFamily="34" charset="-122"/>
+                <a:cs typeface="Arial" pitchFamily="34" charset="-120"/>
+              </a:rPr>
+              <a:t>if our God is for us</a:t>
             </a:r>
             <a:endParaRPr lang="en-US" sz="4800" dirty="0"/>
           </a:p>

</xml_diff>